<commit_message>
revised ch11 and ch10_bst.py
</commit_message>
<xml_diff>
--- a/asset/ppt/ch10_binary_tree.pptx
+++ b/asset/ppt/ch10_binary_tree.pptx
@@ -269,7 +269,7 @@
           <a:p>
             <a:fld id="{89851C12-1240-5B46-BD94-A3C3FBB79758}" type="datetimeFigureOut">
               <a:rPr kumimoji="1" lang="zh-TW" altLang="en-US" smtClean="0"/>
-              <a:t>2026/5/14</a:t>
+              <a:t>2026/5/17</a:t>
             </a:fld>
             <a:endParaRPr kumimoji="1" lang="zh-TW" altLang="en-US"/>
           </a:p>
@@ -467,7 +467,7 @@
           <a:p>
             <a:fld id="{89851C12-1240-5B46-BD94-A3C3FBB79758}" type="datetimeFigureOut">
               <a:rPr kumimoji="1" lang="zh-TW" altLang="en-US" smtClean="0"/>
-              <a:t>2026/5/14</a:t>
+              <a:t>2026/5/17</a:t>
             </a:fld>
             <a:endParaRPr kumimoji="1" lang="zh-TW" altLang="en-US"/>
           </a:p>
@@ -675,7 +675,7 @@
           <a:p>
             <a:fld id="{89851C12-1240-5B46-BD94-A3C3FBB79758}" type="datetimeFigureOut">
               <a:rPr kumimoji="1" lang="zh-TW" altLang="en-US" smtClean="0"/>
-              <a:t>2026/5/14</a:t>
+              <a:t>2026/5/17</a:t>
             </a:fld>
             <a:endParaRPr kumimoji="1" lang="zh-TW" altLang="en-US"/>
           </a:p>
@@ -873,7 +873,7 @@
           <a:p>
             <a:fld id="{89851C12-1240-5B46-BD94-A3C3FBB79758}" type="datetimeFigureOut">
               <a:rPr kumimoji="1" lang="zh-TW" altLang="en-US" smtClean="0"/>
-              <a:t>2026/5/14</a:t>
+              <a:t>2026/5/17</a:t>
             </a:fld>
             <a:endParaRPr kumimoji="1" lang="zh-TW" altLang="en-US"/>
           </a:p>
@@ -1148,7 +1148,7 @@
           <a:p>
             <a:fld id="{89851C12-1240-5B46-BD94-A3C3FBB79758}" type="datetimeFigureOut">
               <a:rPr kumimoji="1" lang="zh-TW" altLang="en-US" smtClean="0"/>
-              <a:t>2026/5/14</a:t>
+              <a:t>2026/5/17</a:t>
             </a:fld>
             <a:endParaRPr kumimoji="1" lang="zh-TW" altLang="en-US"/>
           </a:p>
@@ -1413,7 +1413,7 @@
           <a:p>
             <a:fld id="{89851C12-1240-5B46-BD94-A3C3FBB79758}" type="datetimeFigureOut">
               <a:rPr kumimoji="1" lang="zh-TW" altLang="en-US" smtClean="0"/>
-              <a:t>2026/5/14</a:t>
+              <a:t>2026/5/17</a:t>
             </a:fld>
             <a:endParaRPr kumimoji="1" lang="zh-TW" altLang="en-US"/>
           </a:p>
@@ -1825,7 +1825,7 @@
           <a:p>
             <a:fld id="{89851C12-1240-5B46-BD94-A3C3FBB79758}" type="datetimeFigureOut">
               <a:rPr kumimoji="1" lang="zh-TW" altLang="en-US" smtClean="0"/>
-              <a:t>2026/5/14</a:t>
+              <a:t>2026/5/17</a:t>
             </a:fld>
             <a:endParaRPr kumimoji="1" lang="zh-TW" altLang="en-US"/>
           </a:p>
@@ -1966,7 +1966,7 @@
           <a:p>
             <a:fld id="{89851C12-1240-5B46-BD94-A3C3FBB79758}" type="datetimeFigureOut">
               <a:rPr kumimoji="1" lang="zh-TW" altLang="en-US" smtClean="0"/>
-              <a:t>2026/5/14</a:t>
+              <a:t>2026/5/17</a:t>
             </a:fld>
             <a:endParaRPr kumimoji="1" lang="zh-TW" altLang="en-US"/>
           </a:p>
@@ -2079,7 +2079,7 @@
           <a:p>
             <a:fld id="{89851C12-1240-5B46-BD94-A3C3FBB79758}" type="datetimeFigureOut">
               <a:rPr kumimoji="1" lang="zh-TW" altLang="en-US" smtClean="0"/>
-              <a:t>2026/5/14</a:t>
+              <a:t>2026/5/17</a:t>
             </a:fld>
             <a:endParaRPr kumimoji="1" lang="zh-TW" altLang="en-US"/>
           </a:p>
@@ -2390,7 +2390,7 @@
           <a:p>
             <a:fld id="{89851C12-1240-5B46-BD94-A3C3FBB79758}" type="datetimeFigureOut">
               <a:rPr kumimoji="1" lang="zh-TW" altLang="en-US" smtClean="0"/>
-              <a:t>2026/5/14</a:t>
+              <a:t>2026/5/17</a:t>
             </a:fld>
             <a:endParaRPr kumimoji="1" lang="zh-TW" altLang="en-US"/>
           </a:p>
@@ -2678,7 +2678,7 @@
           <a:p>
             <a:fld id="{89851C12-1240-5B46-BD94-A3C3FBB79758}" type="datetimeFigureOut">
               <a:rPr kumimoji="1" lang="zh-TW" altLang="en-US" smtClean="0"/>
-              <a:t>2026/5/14</a:t>
+              <a:t>2026/5/17</a:t>
             </a:fld>
             <a:endParaRPr kumimoji="1" lang="zh-TW" altLang="en-US"/>
           </a:p>
@@ -2919,7 +2919,7 @@
           <a:p>
             <a:fld id="{89851C12-1240-5B46-BD94-A3C3FBB79758}" type="datetimeFigureOut">
               <a:rPr kumimoji="1" lang="zh-TW" altLang="en-US" smtClean="0"/>
-              <a:t>2026/5/14</a:t>
+              <a:t>2026/5/17</a:t>
             </a:fld>
             <a:endParaRPr kumimoji="1" lang="zh-TW" altLang="en-US"/>
           </a:p>
@@ -10138,6 +10138,19 @@
                 <a:latin typeface="Microsoft JhengHei UI" panose="020B0604030504040204" pitchFamily="34" charset="-120"/>
                 <a:ea typeface="Microsoft JhengHei UI" panose="020B0604030504040204" pitchFamily="34" charset="-120"/>
               </a:rPr>
+              <a:t>0</a:t>
+            </a:r>
+          </a:p>
+          <a:p>
+            <a:pPr algn="ctr"/>
+            <a:r>
+              <a:rPr kumimoji="1" lang="en-US" altLang="zh-TW" sz="1200" dirty="0">
+                <a:solidFill>
+                  <a:schemeClr val="tx1"/>
+                </a:solidFill>
+                <a:latin typeface="Microsoft JhengHei UI" panose="020B0604030504040204" pitchFamily="34" charset="-120"/>
+                <a:ea typeface="Microsoft JhengHei UI" panose="020B0604030504040204" pitchFamily="34" charset="-120"/>
+              </a:rPr>
               <a:t>n</a:t>
             </a:r>
             <a:endParaRPr kumimoji="1" lang="zh-TW" altLang="en-US" sz="1200" dirty="0">
@@ -10213,7 +10226,7 @@
         <p:spPr>
           <a:xfrm>
             <a:off x="83713" y="552960"/>
-            <a:ext cx="7724422" cy="369332"/>
+            <a:ext cx="7872733" cy="369332"/>
           </a:xfrm>
           <a:prstGeom prst="rect">
             <a:avLst/>
@@ -10231,7 +10244,7 @@
                 <a:latin typeface="Microsoft JhengHei UI" panose="020B0604030504040204" pitchFamily="34" charset="-120"/>
                 <a:ea typeface="Microsoft JhengHei UI" panose="020B0604030504040204" pitchFamily="34" charset="-120"/>
               </a:rPr>
-              <a:t>Case 1: (to-be-deleted) node has zero child, the node is root or a leaf</a:t>
+              <a:t>Pattern 1: (to-be-deleted) node has zero child, the node is root or a leaf</a:t>
             </a:r>
             <a:endParaRPr kumimoji="1" lang="zh-TW" altLang="en-US" dirty="0">
               <a:latin typeface="Microsoft JhengHei UI" panose="020B0604030504040204" pitchFamily="34" charset="-120"/>
@@ -10433,6 +10446,19 @@
                     <a:latin typeface="Microsoft JhengHei UI" panose="020B0604030504040204" pitchFamily="34" charset="-120"/>
                     <a:ea typeface="Microsoft JhengHei UI" panose="020B0604030504040204" pitchFamily="34" charset="-120"/>
                   </a:rPr>
+                  <a:t>2</a:t>
+                </a:r>
+              </a:p>
+              <a:p>
+                <a:pPr algn="ctr"/>
+                <a:r>
+                  <a:rPr kumimoji="1" lang="en-US" altLang="zh-TW" sz="1200" dirty="0">
+                    <a:solidFill>
+                      <a:schemeClr val="tx1"/>
+                    </a:solidFill>
+                    <a:latin typeface="Microsoft JhengHei UI" panose="020B0604030504040204" pitchFamily="34" charset="-120"/>
+                    <a:ea typeface="Microsoft JhengHei UI" panose="020B0604030504040204" pitchFamily="34" charset="-120"/>
+                  </a:rPr>
                   <a:t>p</a:t>
                 </a:r>
                 <a:endParaRPr kumimoji="1" lang="zh-TW" altLang="en-US" sz="1200" dirty="0">
@@ -10495,6 +10521,16 @@
               <a:lstStyle/>
               <a:p>
                 <a:pPr algn="ctr"/>
+                <a:r>
+                  <a:rPr kumimoji="1" lang="en-US" altLang="zh-TW" sz="1200" dirty="0">
+                    <a:solidFill>
+                      <a:schemeClr val="tx1"/>
+                    </a:solidFill>
+                    <a:latin typeface="Microsoft JhengHei UI" panose="020B0604030504040204" pitchFamily="34" charset="-120"/>
+                    <a:ea typeface="Microsoft JhengHei UI" panose="020B0604030504040204" pitchFamily="34" charset="-120"/>
+                  </a:rPr>
+                  <a:t>3</a:t>
+                </a:r>
                 <a:endParaRPr kumimoji="1" lang="zh-TW" altLang="en-US" sz="1200" dirty="0">
                   <a:solidFill>
                     <a:schemeClr val="tx1"/>
@@ -10555,6 +10591,16 @@
               <a:lstStyle/>
               <a:p>
                 <a:pPr algn="ctr"/>
+                <a:r>
+                  <a:rPr kumimoji="1" lang="en-US" altLang="zh-TW" sz="1200" dirty="0">
+                    <a:solidFill>
+                      <a:schemeClr val="tx1"/>
+                    </a:solidFill>
+                    <a:latin typeface="Microsoft JhengHei UI" panose="020B0604030504040204" pitchFamily="34" charset="-120"/>
+                    <a:ea typeface="Microsoft JhengHei UI" panose="020B0604030504040204" pitchFamily="34" charset="-120"/>
+                  </a:rPr>
+                  <a:t>4</a:t>
+                </a:r>
                 <a:endParaRPr kumimoji="1" lang="zh-TW" altLang="en-US" sz="1200" dirty="0">
                   <a:solidFill>
                     <a:schemeClr val="tx1"/>
@@ -10613,6 +10659,19 @@
             <p:txBody>
               <a:bodyPr rtlCol="0" anchor="ctr"/>
               <a:lstStyle/>
+              <a:p>
+                <a:pPr algn="ctr"/>
+                <a:r>
+                  <a:rPr kumimoji="1" lang="en-US" altLang="zh-TW" sz="1200" dirty="0">
+                    <a:solidFill>
+                      <a:schemeClr val="tx1"/>
+                    </a:solidFill>
+                    <a:latin typeface="Microsoft JhengHei UI" panose="020B0604030504040204" pitchFamily="34" charset="-120"/>
+                    <a:ea typeface="Microsoft JhengHei UI" panose="020B0604030504040204" pitchFamily="34" charset="-120"/>
+                  </a:rPr>
+                  <a:t>1</a:t>
+                </a:r>
+              </a:p>
               <a:p>
                 <a:pPr algn="ctr"/>
                 <a:r>
@@ -10994,6 +11053,19 @@
                     <a:latin typeface="Microsoft JhengHei UI" panose="020B0604030504040204" pitchFamily="34" charset="-120"/>
                     <a:ea typeface="Microsoft JhengHei UI" panose="020B0604030504040204" pitchFamily="34" charset="-120"/>
                   </a:rPr>
+                  <a:t>2</a:t>
+                </a:r>
+              </a:p>
+              <a:p>
+                <a:pPr algn="ctr"/>
+                <a:r>
+                  <a:rPr kumimoji="1" lang="en-US" altLang="zh-TW" sz="1200" dirty="0">
+                    <a:solidFill>
+                      <a:schemeClr val="tx1"/>
+                    </a:solidFill>
+                    <a:latin typeface="Microsoft JhengHei UI" panose="020B0604030504040204" pitchFamily="34" charset="-120"/>
+                    <a:ea typeface="Microsoft JhengHei UI" panose="020B0604030504040204" pitchFamily="34" charset="-120"/>
+                  </a:rPr>
                   <a:t>p</a:t>
                 </a:r>
                 <a:endParaRPr kumimoji="1" lang="zh-TW" altLang="en-US" sz="1200" dirty="0">
@@ -11056,6 +11128,16 @@
               <a:lstStyle/>
               <a:p>
                 <a:pPr algn="ctr"/>
+                <a:r>
+                  <a:rPr kumimoji="1" lang="en-US" altLang="zh-TW" sz="1200" dirty="0">
+                    <a:solidFill>
+                      <a:schemeClr val="tx1"/>
+                    </a:solidFill>
+                    <a:latin typeface="Microsoft JhengHei UI" panose="020B0604030504040204" pitchFamily="34" charset="-120"/>
+                    <a:ea typeface="Microsoft JhengHei UI" panose="020B0604030504040204" pitchFamily="34" charset="-120"/>
+                  </a:rPr>
+                  <a:t>5</a:t>
+                </a:r>
                 <a:endParaRPr kumimoji="1" lang="zh-TW" altLang="en-US" sz="1200" dirty="0">
                   <a:solidFill>
                     <a:schemeClr val="tx1"/>
@@ -11116,6 +11198,16 @@
               <a:lstStyle/>
               <a:p>
                 <a:pPr algn="ctr"/>
+                <a:r>
+                  <a:rPr kumimoji="1" lang="en-US" altLang="zh-TW" sz="1200" dirty="0">
+                    <a:solidFill>
+                      <a:schemeClr val="tx1"/>
+                    </a:solidFill>
+                    <a:latin typeface="Microsoft JhengHei UI" panose="020B0604030504040204" pitchFamily="34" charset="-120"/>
+                    <a:ea typeface="Microsoft JhengHei UI" panose="020B0604030504040204" pitchFamily="34" charset="-120"/>
+                  </a:rPr>
+                  <a:t>7</a:t>
+                </a:r>
                 <a:endParaRPr kumimoji="1" lang="zh-TW" altLang="en-US" sz="1200" dirty="0">
                   <a:solidFill>
                     <a:schemeClr val="tx1"/>
@@ -11174,6 +11266,19 @@
             <p:txBody>
               <a:bodyPr rtlCol="0" anchor="ctr"/>
               <a:lstStyle/>
+              <a:p>
+                <a:pPr algn="ctr"/>
+                <a:r>
+                  <a:rPr kumimoji="1" lang="en-US" altLang="zh-TW" sz="1200" dirty="0">
+                    <a:solidFill>
+                      <a:schemeClr val="tx1"/>
+                    </a:solidFill>
+                    <a:latin typeface="Microsoft JhengHei UI" panose="020B0604030504040204" pitchFamily="34" charset="-120"/>
+                    <a:ea typeface="Microsoft JhengHei UI" panose="020B0604030504040204" pitchFamily="34" charset="-120"/>
+                  </a:rPr>
+                  <a:t>3</a:t>
+                </a:r>
+              </a:p>
               <a:p>
                 <a:pPr algn="ctr"/>
                 <a:r>
@@ -11386,6 +11491,150 @@
           </p:txBody>
         </p:sp>
       </p:grpSp>
+      <p:sp>
+        <p:nvSpPr>
+          <p:cNvPr id="2" name="文字方塊 1">
+            <a:extLst>
+              <a:ext uri="{FF2B5EF4-FFF2-40B4-BE49-F238E27FC236}">
+                <a16:creationId xmlns:a16="http://schemas.microsoft.com/office/drawing/2014/main" id="{F54CA607-1968-A4F2-AAB7-47C33D67B564}"/>
+              </a:ext>
+            </a:extLst>
+          </p:cNvPr>
+          <p:cNvSpPr txBox="1"/>
+          <p:nvPr/>
+        </p:nvSpPr>
+        <p:spPr>
+          <a:xfrm>
+            <a:off x="414330" y="3215657"/>
+            <a:ext cx="748923" cy="276999"/>
+          </a:xfrm>
+          <a:prstGeom prst="rect">
+            <a:avLst/>
+          </a:prstGeom>
+          <a:noFill/>
+        </p:spPr>
+        <p:txBody>
+          <a:bodyPr wrap="none" rtlCol="0">
+            <a:spAutoFit/>
+          </a:bodyPr>
+          <a:lstStyle/>
+          <a:p>
+            <a:r>
+              <a:rPr kumimoji="1" lang="en-US" altLang="zh-TW" sz="1200" dirty="0">
+                <a:highlight>
+                  <a:srgbClr val="C0C0C0"/>
+                </a:highlight>
+                <a:latin typeface="Microsoft JhengHei UI" panose="020B0604030504040204" pitchFamily="34" charset="-120"/>
+                <a:ea typeface="Microsoft JhengHei UI" panose="020B0604030504040204" pitchFamily="34" charset="-120"/>
+              </a:rPr>
+              <a:t>case1-1</a:t>
+            </a:r>
+            <a:endParaRPr kumimoji="1" lang="zh-TW" altLang="en-US" sz="1200" dirty="0">
+              <a:highlight>
+                <a:srgbClr val="C0C0C0"/>
+              </a:highlight>
+              <a:latin typeface="Microsoft JhengHei UI" panose="020B0604030504040204" pitchFamily="34" charset="-120"/>
+              <a:ea typeface="Microsoft JhengHei UI" panose="020B0604030504040204" pitchFamily="34" charset="-120"/>
+            </a:endParaRPr>
+          </a:p>
+        </p:txBody>
+      </p:sp>
+      <p:sp>
+        <p:nvSpPr>
+          <p:cNvPr id="3" name="文字方塊 2">
+            <a:extLst>
+              <a:ext uri="{FF2B5EF4-FFF2-40B4-BE49-F238E27FC236}">
+                <a16:creationId xmlns:a16="http://schemas.microsoft.com/office/drawing/2014/main" id="{D061B901-E73D-72B4-60FD-AC6BDF201310}"/>
+              </a:ext>
+            </a:extLst>
+          </p:cNvPr>
+          <p:cNvSpPr txBox="1"/>
+          <p:nvPr/>
+        </p:nvSpPr>
+        <p:spPr>
+          <a:xfrm>
+            <a:off x="4129747" y="4172105"/>
+            <a:ext cx="748923" cy="276999"/>
+          </a:xfrm>
+          <a:prstGeom prst="rect">
+            <a:avLst/>
+          </a:prstGeom>
+          <a:noFill/>
+        </p:spPr>
+        <p:txBody>
+          <a:bodyPr wrap="none" rtlCol="0">
+            <a:spAutoFit/>
+          </a:bodyPr>
+          <a:lstStyle/>
+          <a:p>
+            <a:r>
+              <a:rPr kumimoji="1" lang="en-US" altLang="zh-TW" sz="1200" dirty="0">
+                <a:highlight>
+                  <a:srgbClr val="C0C0C0"/>
+                </a:highlight>
+                <a:latin typeface="Microsoft JhengHei UI" panose="020B0604030504040204" pitchFamily="34" charset="-120"/>
+                <a:ea typeface="Microsoft JhengHei UI" panose="020B0604030504040204" pitchFamily="34" charset="-120"/>
+              </a:rPr>
+              <a:t>case1-2</a:t>
+            </a:r>
+            <a:endParaRPr kumimoji="1" lang="zh-TW" altLang="en-US" sz="1200" dirty="0">
+              <a:highlight>
+                <a:srgbClr val="C0C0C0"/>
+              </a:highlight>
+              <a:latin typeface="Microsoft JhengHei UI" panose="020B0604030504040204" pitchFamily="34" charset="-120"/>
+              <a:ea typeface="Microsoft JhengHei UI" panose="020B0604030504040204" pitchFamily="34" charset="-120"/>
+            </a:endParaRPr>
+          </a:p>
+        </p:txBody>
+      </p:sp>
+      <p:sp>
+        <p:nvSpPr>
+          <p:cNvPr id="5" name="文字方塊 4">
+            <a:extLst>
+              <a:ext uri="{FF2B5EF4-FFF2-40B4-BE49-F238E27FC236}">
+                <a16:creationId xmlns:a16="http://schemas.microsoft.com/office/drawing/2014/main" id="{9FF0714E-2BC7-6C16-86CF-06F72BD6BC15}"/>
+              </a:ext>
+            </a:extLst>
+          </p:cNvPr>
+          <p:cNvSpPr txBox="1"/>
+          <p:nvPr/>
+        </p:nvSpPr>
+        <p:spPr>
+          <a:xfrm>
+            <a:off x="7277597" y="4277207"/>
+            <a:ext cx="748923" cy="276999"/>
+          </a:xfrm>
+          <a:prstGeom prst="rect">
+            <a:avLst/>
+          </a:prstGeom>
+          <a:noFill/>
+        </p:spPr>
+        <p:txBody>
+          <a:bodyPr wrap="none" rtlCol="0">
+            <a:spAutoFit/>
+          </a:bodyPr>
+          <a:lstStyle/>
+          <a:p>
+            <a:r>
+              <a:rPr kumimoji="1" lang="en-US" altLang="zh-TW" sz="1200" dirty="0">
+                <a:highlight>
+                  <a:srgbClr val="C0C0C0"/>
+                </a:highlight>
+                <a:latin typeface="Microsoft JhengHei UI" panose="020B0604030504040204" pitchFamily="34" charset="-120"/>
+                <a:ea typeface="Microsoft JhengHei UI" panose="020B0604030504040204" pitchFamily="34" charset="-120"/>
+              </a:rPr>
+              <a:t>case1-3</a:t>
+            </a:r>
+            <a:endParaRPr kumimoji="1" lang="zh-TW" altLang="en-US" sz="1200" dirty="0">
+              <a:highlight>
+                <a:srgbClr val="C0C0C0"/>
+              </a:highlight>
+              <a:latin typeface="Microsoft JhengHei UI" panose="020B0604030504040204" pitchFamily="34" charset="-120"/>
+              <a:ea typeface="Microsoft JhengHei UI" panose="020B0604030504040204" pitchFamily="34" charset="-120"/>
+            </a:endParaRPr>
+          </a:p>
+        </p:txBody>
+      </p:sp>
     </p:spTree>
     <p:extLst>
       <p:ext uri="{BB962C8B-B14F-4D97-AF65-F5344CB8AC3E}">
@@ -11437,7 +11686,7 @@
         <p:spPr>
           <a:xfrm>
             <a:off x="98367" y="569997"/>
-            <a:ext cx="4778231" cy="369332"/>
+            <a:ext cx="5049972" cy="369332"/>
           </a:xfrm>
           <a:prstGeom prst="rect">
             <a:avLst/>
@@ -11455,7 +11704,7 @@
                 <a:latin typeface="Microsoft JhengHei UI" panose="020B0604030504040204" pitchFamily="34" charset="-120"/>
                 <a:ea typeface="Microsoft JhengHei UI" panose="020B0604030504040204" pitchFamily="34" charset="-120"/>
               </a:rPr>
-              <a:t>Case 2: (to-be-deleted) node has one child</a:t>
+              <a:t>Pattern 2: (to-be-deleted) node has one child</a:t>
             </a:r>
             <a:endParaRPr kumimoji="1" lang="zh-TW" altLang="en-US" u="sng" dirty="0">
               <a:latin typeface="Microsoft JhengHei UI" panose="020B0604030504040204" pitchFamily="34" charset="-120"/>
@@ -11542,6 +11791,19 @@
                   <a:latin typeface="Microsoft JhengHei UI" panose="020B0604030504040204" pitchFamily="34" charset="-120"/>
                   <a:ea typeface="Microsoft JhengHei UI" panose="020B0604030504040204" pitchFamily="34" charset="-120"/>
                 </a:rPr>
+                <a:t>4</a:t>
+              </a:r>
+            </a:p>
+            <a:p>
+              <a:pPr algn="ctr"/>
+              <a:r>
+                <a:rPr kumimoji="1" lang="en-US" altLang="zh-TW" sz="1400" dirty="0">
+                  <a:solidFill>
+                    <a:schemeClr val="tx1"/>
+                  </a:solidFill>
+                  <a:latin typeface="Microsoft JhengHei UI" panose="020B0604030504040204" pitchFamily="34" charset="-120"/>
+                  <a:ea typeface="Microsoft JhengHei UI" panose="020B0604030504040204" pitchFamily="34" charset="-120"/>
+                </a:rPr>
                 <a:t>n</a:t>
               </a:r>
               <a:endParaRPr kumimoji="1" lang="zh-TW" altLang="en-US" sz="1400" dirty="0">
@@ -11602,6 +11864,19 @@
           <p:txBody>
             <a:bodyPr rtlCol="0" anchor="ctr"/>
             <a:lstStyle/>
+            <a:p>
+              <a:pPr algn="ctr"/>
+              <a:r>
+                <a:rPr kumimoji="1" lang="en-US" altLang="zh-TW" sz="1400" dirty="0">
+                  <a:solidFill>
+                    <a:schemeClr val="tx1"/>
+                  </a:solidFill>
+                  <a:latin typeface="Microsoft JhengHei UI" panose="020B0604030504040204" pitchFamily="34" charset="-120"/>
+                  <a:ea typeface="Microsoft JhengHei UI" panose="020B0604030504040204" pitchFamily="34" charset="-120"/>
+                </a:rPr>
+                <a:t>5</a:t>
+              </a:r>
+            </a:p>
             <a:p>
               <a:pPr algn="ctr"/>
               <a:r>
@@ -11674,7 +11949,17 @@
             <a:lstStyle/>
             <a:p>
               <a:pPr algn="ctr"/>
-              <a:endParaRPr kumimoji="1" lang="zh-TW" altLang="en-US" dirty="0">
+              <a:r>
+                <a:rPr kumimoji="1" lang="en-US" altLang="zh-TW" sz="1200" dirty="0">
+                  <a:solidFill>
+                    <a:schemeClr val="tx1"/>
+                  </a:solidFill>
+                  <a:latin typeface="Microsoft JhengHei UI" panose="020B0604030504040204" pitchFamily="34" charset="-120"/>
+                  <a:ea typeface="Microsoft JhengHei UI" panose="020B0604030504040204" pitchFamily="34" charset="-120"/>
+                </a:rPr>
+                <a:t>7</a:t>
+              </a:r>
+              <a:endParaRPr kumimoji="1" lang="zh-TW" altLang="en-US" sz="1200" dirty="0">
                 <a:solidFill>
                   <a:schemeClr val="tx1"/>
                 </a:solidFill>
@@ -11698,8 +11983,8 @@
           </p:nvSpPr>
           <p:spPr>
             <a:xfrm>
-              <a:off x="4878905" y="3136709"/>
-              <a:ext cx="540000" cy="540000"/>
+              <a:off x="4773633" y="3136709"/>
+              <a:ext cx="645272" cy="599635"/>
             </a:xfrm>
             <a:prstGeom prst="ellipse">
               <a:avLst/>
@@ -11732,6 +12017,19 @@
           <p:txBody>
             <a:bodyPr rtlCol="0" anchor="ctr"/>
             <a:lstStyle/>
+            <a:p>
+              <a:pPr algn="ctr"/>
+              <a:r>
+                <a:rPr kumimoji="1" lang="en-US" altLang="zh-TW" sz="800" dirty="0">
+                  <a:solidFill>
+                    <a:schemeClr val="tx1"/>
+                  </a:solidFill>
+                  <a:latin typeface="Microsoft JhengHei UI" panose="020B0604030504040204" pitchFamily="34" charset="-120"/>
+                  <a:ea typeface="Microsoft JhengHei UI" panose="020B0604030504040204" pitchFamily="34" charset="-120"/>
+                </a:rPr>
+                <a:t>2</a:t>
+              </a:r>
+            </a:p>
             <a:p>
               <a:pPr algn="ctr"/>
               <a:r>
@@ -11866,8 +12164,8 @@
           </p:nvCxnSpPr>
           <p:spPr>
             <a:xfrm flipH="1">
-              <a:off x="5148905" y="2914708"/>
-              <a:ext cx="371063" cy="222001"/>
+              <a:off x="5096269" y="2914709"/>
+              <a:ext cx="423700" cy="222000"/>
             </a:xfrm>
             <a:prstGeom prst="line">
               <a:avLst/>
@@ -12008,6 +12306,16 @@
             <a:lstStyle/>
             <a:p>
               <a:pPr algn="ctr"/>
+              <a:r>
+                <a:rPr kumimoji="1" lang="en-US" altLang="zh-TW" sz="1000" dirty="0">
+                  <a:solidFill>
+                    <a:schemeClr val="tx1"/>
+                  </a:solidFill>
+                  <a:latin typeface="Microsoft JhengHei UI" panose="020B0604030504040204" pitchFamily="34" charset="-120"/>
+                  <a:ea typeface="Microsoft JhengHei UI" panose="020B0604030504040204" pitchFamily="34" charset="-120"/>
+                </a:rPr>
+                <a:t>1</a:t>
+              </a:r>
               <a:endParaRPr kumimoji="1" lang="zh-TW" altLang="en-US" sz="1000" dirty="0">
                 <a:solidFill>
                   <a:schemeClr val="tx1"/>
@@ -12068,6 +12376,16 @@
             <a:lstStyle/>
             <a:p>
               <a:pPr algn="ctr"/>
+              <a:r>
+                <a:rPr kumimoji="1" lang="en-US" altLang="zh-TW" sz="1000" dirty="0">
+                  <a:solidFill>
+                    <a:schemeClr val="tx1"/>
+                  </a:solidFill>
+                  <a:latin typeface="Microsoft JhengHei UI" panose="020B0604030504040204" pitchFamily="34" charset="-120"/>
+                  <a:ea typeface="Microsoft JhengHei UI" panose="020B0604030504040204" pitchFamily="34" charset="-120"/>
+                </a:rPr>
+                <a:t>3</a:t>
+              </a:r>
               <a:endParaRPr kumimoji="1" lang="zh-TW" altLang="en-US" sz="1000" dirty="0">
                 <a:solidFill>
                   <a:schemeClr val="tx1"/>
@@ -12096,8 +12414,8 @@
           </p:nvCxnSpPr>
           <p:spPr>
             <a:xfrm flipH="1">
-              <a:off x="4824227" y="3676709"/>
-              <a:ext cx="324678" cy="221999"/>
+              <a:off x="4824228" y="3736344"/>
+              <a:ext cx="272042" cy="162364"/>
             </a:xfrm>
             <a:prstGeom prst="line">
               <a:avLst/>
@@ -12143,8 +12461,8 @@
           </p:nvCxnSpPr>
           <p:spPr>
             <a:xfrm>
-              <a:off x="5148905" y="3676709"/>
-              <a:ext cx="397567" cy="215375"/>
+              <a:off x="5096269" y="3736344"/>
+              <a:ext cx="450203" cy="155740"/>
             </a:xfrm>
             <a:prstGeom prst="line">
               <a:avLst/>
@@ -12243,6 +12561,16 @@
             <a:lstStyle/>
             <a:p>
               <a:pPr algn="ctr"/>
+              <a:r>
+                <a:rPr kumimoji="1" lang="en-US" altLang="zh-TW" sz="1400" dirty="0">
+                  <a:solidFill>
+                    <a:schemeClr val="tx1"/>
+                  </a:solidFill>
+                  <a:latin typeface="Microsoft JhengHei UI" panose="020B0604030504040204" pitchFamily="34" charset="-120"/>
+                  <a:ea typeface="Microsoft JhengHei UI" panose="020B0604030504040204" pitchFamily="34" charset="-120"/>
+                </a:rPr>
+                <a:t>1</a:t>
+              </a:r>
               <a:endParaRPr kumimoji="1" lang="zh-TW" altLang="en-US" sz="1400" dirty="0">
                 <a:solidFill>
                   <a:schemeClr val="tx1"/>
@@ -12311,7 +12639,7 @@
                   <a:latin typeface="Microsoft JhengHei UI" panose="020B0604030504040204" pitchFamily="34" charset="-120"/>
                   <a:ea typeface="Microsoft JhengHei UI" panose="020B0604030504040204" pitchFamily="34" charset="-120"/>
                 </a:rPr>
-                <a:t>p</a:t>
+                <a:t>3p</a:t>
               </a:r>
               <a:endParaRPr kumimoji="1" lang="zh-TW" altLang="en-US" sz="1400" dirty="0">
                 <a:solidFill>
@@ -12373,6 +12701,16 @@
             <a:lstStyle/>
             <a:p>
               <a:pPr algn="ctr"/>
+              <a:endParaRPr kumimoji="1" lang="en-US" altLang="zh-TW" sz="1200" dirty="0">
+                <a:solidFill>
+                  <a:schemeClr val="tx1"/>
+                </a:solidFill>
+                <a:latin typeface="Microsoft JhengHei UI" panose="020B0604030504040204" pitchFamily="34" charset="-120"/>
+                <a:ea typeface="Microsoft JhengHei UI" panose="020B0604030504040204" pitchFamily="34" charset="-120"/>
+              </a:endParaRPr>
+            </a:p>
+            <a:p>
+              <a:pPr algn="ctr"/>
               <a:r>
                 <a:rPr kumimoji="1" lang="en-US" altLang="zh-TW" sz="1200" dirty="0">
                   <a:solidFill>
@@ -12381,7 +12719,7 @@
                   <a:latin typeface="Microsoft JhengHei UI" panose="020B0604030504040204" pitchFamily="34" charset="-120"/>
                   <a:ea typeface="Microsoft JhengHei UI" panose="020B0604030504040204" pitchFamily="34" charset="-120"/>
                 </a:rPr>
-                <a:t>n</a:t>
+                <a:t>8n</a:t>
               </a:r>
               <a:endParaRPr kumimoji="1" lang="zh-TW" altLang="en-US" sz="1200" dirty="0">
                 <a:solidFill>
@@ -12407,8 +12745,8 @@
           </p:nvSpPr>
           <p:spPr>
             <a:xfrm>
-              <a:off x="5699905" y="3136709"/>
-              <a:ext cx="540000" cy="540001"/>
+              <a:off x="5534892" y="3136708"/>
+              <a:ext cx="705013" cy="640089"/>
             </a:xfrm>
             <a:prstGeom prst="ellipse">
               <a:avLst/>
@@ -12441,6 +12779,19 @@
           <p:txBody>
             <a:bodyPr rtlCol="0" anchor="ctr"/>
             <a:lstStyle/>
+            <a:p>
+              <a:pPr algn="ctr"/>
+              <a:r>
+                <a:rPr kumimoji="1" lang="en-US" altLang="zh-TW" sz="800" dirty="0">
+                  <a:solidFill>
+                    <a:schemeClr val="tx1"/>
+                  </a:solidFill>
+                  <a:latin typeface="Microsoft JhengHei UI" panose="020B0604030504040204" pitchFamily="34" charset="-120"/>
+                  <a:ea typeface="Microsoft JhengHei UI" panose="020B0604030504040204" pitchFamily="34" charset="-120"/>
+                </a:rPr>
+                <a:t>5</a:t>
+              </a:r>
+            </a:p>
             <a:p>
               <a:pPr algn="ctr"/>
               <a:r>
@@ -12575,8 +12926,8 @@
           </p:nvCxnSpPr>
           <p:spPr>
             <a:xfrm flipH="1">
-              <a:off x="5969905" y="2848449"/>
-              <a:ext cx="252428" cy="288260"/>
+              <a:off x="5887399" y="2848447"/>
+              <a:ext cx="334935" cy="288261"/>
             </a:xfrm>
             <a:prstGeom prst="line">
               <a:avLst/>
@@ -12717,6 +13068,16 @@
             <a:lstStyle/>
             <a:p>
               <a:pPr algn="ctr"/>
+              <a:r>
+                <a:rPr kumimoji="1" lang="en-US" altLang="zh-TW" sz="1000" dirty="0">
+                  <a:solidFill>
+                    <a:schemeClr val="tx1"/>
+                  </a:solidFill>
+                  <a:latin typeface="Microsoft JhengHei UI" panose="020B0604030504040204" pitchFamily="34" charset="-120"/>
+                  <a:ea typeface="Microsoft JhengHei UI" panose="020B0604030504040204" pitchFamily="34" charset="-120"/>
+                </a:rPr>
+                <a:t>4</a:t>
+              </a:r>
               <a:endParaRPr kumimoji="1" lang="zh-TW" altLang="en-US" sz="1000" dirty="0">
                 <a:solidFill>
                   <a:schemeClr val="tx1"/>
@@ -12777,6 +13138,16 @@
             <a:lstStyle/>
             <a:p>
               <a:pPr algn="ctr"/>
+              <a:r>
+                <a:rPr kumimoji="1" lang="en-US" altLang="zh-TW" sz="1000" dirty="0">
+                  <a:solidFill>
+                    <a:schemeClr val="tx1"/>
+                  </a:solidFill>
+                  <a:latin typeface="Microsoft JhengHei UI" panose="020B0604030504040204" pitchFamily="34" charset="-120"/>
+                  <a:ea typeface="Microsoft JhengHei UI" panose="020B0604030504040204" pitchFamily="34" charset="-120"/>
+                </a:rPr>
+                <a:t>6</a:t>
+              </a:r>
               <a:endParaRPr kumimoji="1" lang="zh-TW" altLang="en-US" sz="1000" dirty="0">
                 <a:solidFill>
                   <a:schemeClr val="tx1"/>
@@ -12805,8 +13176,8 @@
           </p:nvCxnSpPr>
           <p:spPr>
             <a:xfrm flipH="1">
-              <a:off x="5645227" y="3676710"/>
-              <a:ext cx="324679" cy="221997"/>
+              <a:off x="5645227" y="3776797"/>
+              <a:ext cx="242172" cy="121911"/>
             </a:xfrm>
             <a:prstGeom prst="line">
               <a:avLst/>
@@ -12852,8 +13223,8 @@
           </p:nvCxnSpPr>
           <p:spPr>
             <a:xfrm>
-              <a:off x="5969905" y="3676710"/>
-              <a:ext cx="397566" cy="215374"/>
+              <a:off x="5887399" y="3776797"/>
+              <a:ext cx="480072" cy="115287"/>
             </a:xfrm>
             <a:prstGeom prst="line">
               <a:avLst/>
@@ -12960,7 +13331,7 @@
                   <a:latin typeface="Microsoft JhengHei UI" panose="020B0604030504040204" pitchFamily="34" charset="-120"/>
                   <a:ea typeface="Microsoft JhengHei UI" panose="020B0604030504040204" pitchFamily="34" charset="-120"/>
                 </a:rPr>
-                <a:t>n</a:t>
+                <a:t>3n</a:t>
               </a:r>
               <a:endParaRPr kumimoji="1" lang="zh-TW" altLang="en-US" sz="1400" dirty="0">
                 <a:solidFill>
@@ -13020,6 +13391,19 @@
           <p:txBody>
             <a:bodyPr rtlCol="0" anchor="ctr"/>
             <a:lstStyle/>
+            <a:p>
+              <a:pPr algn="ctr"/>
+              <a:r>
+                <a:rPr kumimoji="1" lang="en-US" altLang="zh-TW" sz="1400" dirty="0">
+                  <a:solidFill>
+                    <a:schemeClr val="tx1"/>
+                  </a:solidFill>
+                  <a:latin typeface="Microsoft JhengHei UI" panose="020B0604030504040204" pitchFamily="34" charset="-120"/>
+                  <a:ea typeface="Microsoft JhengHei UI" panose="020B0604030504040204" pitchFamily="34" charset="-120"/>
+                </a:rPr>
+                <a:t>7</a:t>
+              </a:r>
+            </a:p>
             <a:p>
               <a:pPr algn="ctr"/>
               <a:r>
@@ -13092,7 +13476,17 @@
             <a:lstStyle/>
             <a:p>
               <a:pPr algn="ctr"/>
-              <a:endParaRPr kumimoji="1" lang="zh-TW" altLang="en-US" dirty="0">
+              <a:r>
+                <a:rPr kumimoji="1" lang="en-US" altLang="zh-TW" sz="1100" dirty="0">
+                  <a:solidFill>
+                    <a:schemeClr val="tx1"/>
+                  </a:solidFill>
+                  <a:latin typeface="Microsoft JhengHei UI" panose="020B0604030504040204" pitchFamily="34" charset="-120"/>
+                  <a:ea typeface="Microsoft JhengHei UI" panose="020B0604030504040204" pitchFamily="34" charset="-120"/>
+                </a:rPr>
+                <a:t>9</a:t>
+              </a:r>
+              <a:endParaRPr kumimoji="1" lang="zh-TW" altLang="en-US" sz="1100" dirty="0">
                 <a:solidFill>
                   <a:schemeClr val="tx1"/>
                 </a:solidFill>
@@ -13117,7 +13511,7 @@
           <p:spPr>
             <a:xfrm>
               <a:off x="5732100" y="3136709"/>
-              <a:ext cx="540000" cy="540001"/>
+              <a:ext cx="736143" cy="647688"/>
             </a:xfrm>
             <a:prstGeom prst="ellipse">
               <a:avLst/>
@@ -13150,6 +13544,19 @@
           <p:txBody>
             <a:bodyPr rtlCol="0" anchor="ctr"/>
             <a:lstStyle/>
+            <a:p>
+              <a:pPr algn="ctr"/>
+              <a:r>
+                <a:rPr kumimoji="1" lang="en-US" altLang="zh-TW" sz="800" dirty="0">
+                  <a:solidFill>
+                    <a:schemeClr val="tx1"/>
+                  </a:solidFill>
+                  <a:latin typeface="Microsoft JhengHei UI" panose="020B0604030504040204" pitchFamily="34" charset="-120"/>
+                  <a:ea typeface="Microsoft JhengHei UI" panose="020B0604030504040204" pitchFamily="34" charset="-120"/>
+                </a:rPr>
+                <a:t>5</a:t>
+              </a:r>
+            </a:p>
             <a:p>
               <a:pPr algn="ctr"/>
               <a:r>
@@ -13285,7 +13692,7 @@
           <p:spPr>
             <a:xfrm>
               <a:off x="5519969" y="2914708"/>
-              <a:ext cx="482132" cy="222001"/>
+              <a:ext cx="580203" cy="222001"/>
             </a:xfrm>
             <a:prstGeom prst="line">
               <a:avLst/>
@@ -13426,6 +13833,16 @@
             <a:lstStyle/>
             <a:p>
               <a:pPr algn="ctr"/>
+              <a:r>
+                <a:rPr kumimoji="1" lang="en-US" altLang="zh-TW" sz="1000" dirty="0">
+                  <a:solidFill>
+                    <a:schemeClr val="tx1"/>
+                  </a:solidFill>
+                  <a:latin typeface="Microsoft JhengHei UI" panose="020B0604030504040204" pitchFamily="34" charset="-120"/>
+                  <a:ea typeface="Microsoft JhengHei UI" panose="020B0604030504040204" pitchFamily="34" charset="-120"/>
+                </a:rPr>
+                <a:t>4</a:t>
+              </a:r>
               <a:endParaRPr kumimoji="1" lang="zh-TW" altLang="en-US" sz="1000" dirty="0">
                 <a:solidFill>
                   <a:schemeClr val="tx1"/>
@@ -13486,6 +13903,16 @@
             <a:lstStyle/>
             <a:p>
               <a:pPr algn="ctr"/>
+              <a:r>
+                <a:rPr kumimoji="1" lang="en-US" altLang="zh-TW" sz="1000" dirty="0">
+                  <a:solidFill>
+                    <a:schemeClr val="tx1"/>
+                  </a:solidFill>
+                  <a:latin typeface="Microsoft JhengHei UI" panose="020B0604030504040204" pitchFamily="34" charset="-120"/>
+                  <a:ea typeface="Microsoft JhengHei UI" panose="020B0604030504040204" pitchFamily="34" charset="-120"/>
+                </a:rPr>
+                <a:t>6</a:t>
+              </a:r>
               <a:endParaRPr kumimoji="1" lang="zh-TW" altLang="en-US" sz="1000" dirty="0">
                 <a:solidFill>
                   <a:schemeClr val="tx1"/>
@@ -13514,8 +13941,8 @@
           </p:nvCxnSpPr>
           <p:spPr>
             <a:xfrm flipH="1">
-              <a:off x="5677423" y="3676710"/>
-              <a:ext cx="324677" cy="221997"/>
+              <a:off x="5677424" y="3784397"/>
+              <a:ext cx="422748" cy="114310"/>
             </a:xfrm>
             <a:prstGeom prst="line">
               <a:avLst/>
@@ -13561,8 +13988,8 @@
           </p:nvCxnSpPr>
           <p:spPr>
             <a:xfrm>
-              <a:off x="6002101" y="3676710"/>
-              <a:ext cx="397563" cy="215374"/>
+              <a:off x="6100172" y="3784397"/>
+              <a:ext cx="299492" cy="107687"/>
             </a:xfrm>
             <a:prstGeom prst="line">
               <a:avLst/>
@@ -13661,6 +14088,16 @@
             <a:lstStyle/>
             <a:p>
               <a:pPr algn="ctr"/>
+              <a:r>
+                <a:rPr kumimoji="1" lang="en-US" altLang="zh-TW" sz="1400" dirty="0">
+                  <a:solidFill>
+                    <a:schemeClr val="tx1"/>
+                  </a:solidFill>
+                  <a:latin typeface="Microsoft JhengHei UI" panose="020B0604030504040204" pitchFamily="34" charset="-120"/>
+                  <a:ea typeface="Microsoft JhengHei UI" panose="020B0604030504040204" pitchFamily="34" charset="-120"/>
+                </a:rPr>
+                <a:t>1</a:t>
+              </a:r>
               <a:endParaRPr kumimoji="1" lang="zh-TW" altLang="en-US" sz="1400" dirty="0">
                 <a:solidFill>
                   <a:schemeClr val="tx1"/>
@@ -13719,6 +14156,19 @@
           <p:txBody>
             <a:bodyPr rtlCol="0" anchor="ctr"/>
             <a:lstStyle/>
+            <a:p>
+              <a:pPr algn="ctr"/>
+              <a:r>
+                <a:rPr kumimoji="1" lang="en-US" altLang="zh-TW" sz="1400" dirty="0">
+                  <a:solidFill>
+                    <a:schemeClr val="tx1"/>
+                  </a:solidFill>
+                  <a:latin typeface="Microsoft JhengHei UI" panose="020B0604030504040204" pitchFamily="34" charset="-120"/>
+                  <a:ea typeface="Microsoft JhengHei UI" panose="020B0604030504040204" pitchFamily="34" charset="-120"/>
+                </a:rPr>
+                <a:t>3</a:t>
+              </a:r>
+            </a:p>
             <a:p>
               <a:pPr algn="ctr"/>
               <a:r>
@@ -13799,6 +14249,19 @@
                   <a:latin typeface="Microsoft JhengHei UI" panose="020B0604030504040204" pitchFamily="34" charset="-120"/>
                   <a:ea typeface="Microsoft JhengHei UI" panose="020B0604030504040204" pitchFamily="34" charset="-120"/>
                 </a:rPr>
+                <a:t>5</a:t>
+              </a:r>
+            </a:p>
+            <a:p>
+              <a:pPr algn="ctr"/>
+              <a:r>
+                <a:rPr kumimoji="1" lang="en-US" altLang="zh-TW" sz="1200" dirty="0">
+                  <a:solidFill>
+                    <a:schemeClr val="tx1"/>
+                  </a:solidFill>
+                  <a:latin typeface="Microsoft JhengHei UI" panose="020B0604030504040204" pitchFamily="34" charset="-120"/>
+                  <a:ea typeface="Microsoft JhengHei UI" panose="020B0604030504040204" pitchFamily="34" charset="-120"/>
+                </a:rPr>
                 <a:t>n</a:t>
               </a:r>
               <a:endParaRPr kumimoji="1" lang="zh-TW" altLang="en-US" sz="1200" dirty="0">
@@ -13825,8 +14288,8 @@
           </p:nvSpPr>
           <p:spPr>
             <a:xfrm>
-              <a:off x="6359922" y="3136709"/>
-              <a:ext cx="540000" cy="540001"/>
+              <a:off x="6247316" y="3136708"/>
+              <a:ext cx="652607" cy="697958"/>
             </a:xfrm>
             <a:prstGeom prst="ellipse">
               <a:avLst/>
@@ -13859,6 +14322,19 @@
           <p:txBody>
             <a:bodyPr rtlCol="0" anchor="ctr"/>
             <a:lstStyle/>
+            <a:p>
+              <a:pPr algn="ctr"/>
+              <a:r>
+                <a:rPr kumimoji="1" lang="en-US" altLang="zh-TW" sz="800" dirty="0">
+                  <a:solidFill>
+                    <a:schemeClr val="tx1"/>
+                  </a:solidFill>
+                  <a:latin typeface="Microsoft JhengHei UI" panose="020B0604030504040204" pitchFamily="34" charset="-120"/>
+                  <a:ea typeface="Microsoft JhengHei UI" panose="020B0604030504040204" pitchFamily="34" charset="-120"/>
+                </a:rPr>
+                <a:t>8</a:t>
+              </a:r>
+            </a:p>
             <a:p>
               <a:pPr algn="ctr"/>
               <a:r>
@@ -13994,7 +14470,7 @@
           <p:spPr>
             <a:xfrm>
               <a:off x="6222333" y="2848449"/>
-              <a:ext cx="407590" cy="288260"/>
+              <a:ext cx="351286" cy="288259"/>
             </a:xfrm>
             <a:prstGeom prst="line">
               <a:avLst/>
@@ -14177,6 +14653,16 @@
             <a:lstStyle/>
             <a:p>
               <a:pPr algn="ctr"/>
+              <a:r>
+                <a:rPr kumimoji="1" lang="en-US" altLang="zh-TW" sz="1000" dirty="0">
+                  <a:solidFill>
+                    <a:schemeClr val="tx1"/>
+                  </a:solidFill>
+                  <a:latin typeface="Microsoft JhengHei UI" panose="020B0604030504040204" pitchFamily="34" charset="-120"/>
+                  <a:ea typeface="Microsoft JhengHei UI" panose="020B0604030504040204" pitchFamily="34" charset="-120"/>
+                </a:rPr>
+                <a:t>6</a:t>
+              </a:r>
               <a:endParaRPr kumimoji="1" lang="zh-TW" altLang="en-US" sz="1000" dirty="0">
                 <a:solidFill>
                   <a:schemeClr val="tx1"/>
@@ -14237,6 +14723,16 @@
             <a:lstStyle/>
             <a:p>
               <a:pPr algn="ctr"/>
+              <a:r>
+                <a:rPr kumimoji="1" lang="en-US" altLang="zh-TW" sz="1000" dirty="0">
+                  <a:solidFill>
+                    <a:schemeClr val="tx1"/>
+                  </a:solidFill>
+                  <a:latin typeface="Microsoft JhengHei UI" panose="020B0604030504040204" pitchFamily="34" charset="-120"/>
+                  <a:ea typeface="Microsoft JhengHei UI" panose="020B0604030504040204" pitchFamily="34" charset="-120"/>
+                </a:rPr>
+                <a:t>9</a:t>
+              </a:r>
               <a:endParaRPr kumimoji="1" lang="zh-TW" altLang="en-US" sz="1000" dirty="0">
                 <a:solidFill>
                   <a:schemeClr val="tx1"/>
@@ -14265,8 +14761,8 @@
           </p:nvCxnSpPr>
           <p:spPr>
             <a:xfrm flipH="1">
-              <a:off x="6305244" y="3676710"/>
-              <a:ext cx="324679" cy="221997"/>
+              <a:off x="6305244" y="3834666"/>
+              <a:ext cx="268375" cy="64042"/>
             </a:xfrm>
             <a:prstGeom prst="line">
               <a:avLst/>
@@ -14312,8 +14808,8 @@
           </p:nvCxnSpPr>
           <p:spPr>
             <a:xfrm>
-              <a:off x="6629923" y="3676710"/>
-              <a:ext cx="397566" cy="215374"/>
+              <a:off x="6573619" y="3834666"/>
+              <a:ext cx="453869" cy="57418"/>
             </a:xfrm>
             <a:prstGeom prst="line">
               <a:avLst/>
@@ -14427,10 +14923,10 @@
         </p:nvGrpSpPr>
         <p:grpSpPr>
           <a:xfrm>
-            <a:off x="2185349" y="1823932"/>
-            <a:ext cx="2213379" cy="2668604"/>
-            <a:chOff x="2289034" y="359655"/>
-            <a:chExt cx="2303938" cy="2668604"/>
+            <a:off x="2011923" y="1823932"/>
+            <a:ext cx="2386805" cy="2668604"/>
+            <a:chOff x="2108513" y="359655"/>
+            <a:chExt cx="2484459" cy="2668604"/>
           </a:xfrm>
         </p:grpSpPr>
         <p:sp>
@@ -14447,8 +14943,8 @@
           </p:nvSpPr>
           <p:spPr>
             <a:xfrm>
-              <a:off x="2289034" y="1759396"/>
-              <a:ext cx="540000" cy="540000"/>
+              <a:off x="2108513" y="1759395"/>
+              <a:ext cx="834679" cy="646331"/>
             </a:xfrm>
             <a:prstGeom prst="ellipse">
               <a:avLst/>
@@ -14481,6 +14977,19 @@
           <p:txBody>
             <a:bodyPr rtlCol="0" anchor="ctr"/>
             <a:lstStyle/>
+            <a:p>
+              <a:pPr algn="ctr"/>
+              <a:r>
+                <a:rPr kumimoji="1" lang="en-US" altLang="zh-TW" sz="1200" dirty="0">
+                  <a:solidFill>
+                    <a:schemeClr val="tx1"/>
+                  </a:solidFill>
+                  <a:latin typeface="Microsoft JhengHei UI" panose="020B0604030504040204" pitchFamily="34" charset="-120"/>
+                  <a:ea typeface="Microsoft JhengHei UI" panose="020B0604030504040204" pitchFamily="34" charset="-120"/>
+                </a:rPr>
+                <a:t>1</a:t>
+              </a:r>
+            </a:p>
             <a:p>
               <a:pPr algn="ctr"/>
               <a:r>
@@ -14561,6 +15070,19 @@
                   <a:latin typeface="Microsoft JhengHei UI" panose="020B0604030504040204" pitchFamily="34" charset="-120"/>
                   <a:ea typeface="Microsoft JhengHei UI" panose="020B0604030504040204" pitchFamily="34" charset="-120"/>
                 </a:rPr>
+                <a:t>3</a:t>
+              </a:r>
+            </a:p>
+            <a:p>
+              <a:pPr algn="ctr"/>
+              <a:r>
+                <a:rPr kumimoji="1" lang="en-US" altLang="zh-TW" sz="1200" dirty="0">
+                  <a:solidFill>
+                    <a:schemeClr val="tx1"/>
+                  </a:solidFill>
+                  <a:latin typeface="Microsoft JhengHei UI" panose="020B0604030504040204" pitchFamily="34" charset="-120"/>
+                  <a:ea typeface="Microsoft JhengHei UI" panose="020B0604030504040204" pitchFamily="34" charset="-120"/>
+                </a:rPr>
                 <a:t>n</a:t>
               </a:r>
               <a:endParaRPr kumimoji="1" lang="zh-TW" altLang="en-US" sz="1200" dirty="0">
@@ -14587,7 +15109,7 @@
           </p:nvSpPr>
           <p:spPr>
             <a:xfrm>
-              <a:off x="2583713" y="2488259"/>
+              <a:off x="2747824" y="2488259"/>
               <a:ext cx="540000" cy="540000"/>
             </a:xfrm>
             <a:prstGeom prst="ellipse">
@@ -14623,6 +15145,16 @@
             <a:lstStyle/>
             <a:p>
               <a:pPr algn="ctr"/>
+              <a:r>
+                <a:rPr kumimoji="1" lang="en-US" altLang="zh-TW" sz="1200" dirty="0">
+                  <a:solidFill>
+                    <a:schemeClr val="tx1"/>
+                  </a:solidFill>
+                  <a:latin typeface="Microsoft JhengHei UI" panose="020B0604030504040204" pitchFamily="34" charset="-120"/>
+                  <a:ea typeface="Microsoft JhengHei UI" panose="020B0604030504040204" pitchFamily="34" charset="-120"/>
+                </a:rPr>
+                <a:t>2</a:t>
+              </a:r>
               <a:endParaRPr kumimoji="1" lang="zh-TW" altLang="en-US" sz="1200" dirty="0">
                 <a:solidFill>
                   <a:schemeClr val="tx1"/>
@@ -14651,8 +15183,8 @@
           </p:nvCxnSpPr>
           <p:spPr>
             <a:xfrm flipH="1">
-              <a:off x="2559034" y="1537396"/>
-              <a:ext cx="284924" cy="222000"/>
+              <a:off x="2525853" y="1537396"/>
+              <a:ext cx="318105" cy="221999"/>
             </a:xfrm>
             <a:prstGeom prst="line">
               <a:avLst/>
@@ -14698,8 +15230,8 @@
           </p:nvCxnSpPr>
           <p:spPr>
             <a:xfrm>
-              <a:off x="2559034" y="2299396"/>
-              <a:ext cx="294679" cy="188863"/>
+              <a:off x="2525853" y="2405726"/>
+              <a:ext cx="491971" cy="82533"/>
             </a:xfrm>
             <a:prstGeom prst="line">
               <a:avLst/>
@@ -14799,9 +15331,9 @@
         <p:grpSpPr>
           <a:xfrm>
             <a:off x="249196" y="1818868"/>
-            <a:ext cx="1987902" cy="1937319"/>
+            <a:ext cx="1987902" cy="2043649"/>
             <a:chOff x="1873635" y="362077"/>
-            <a:chExt cx="1987902" cy="1937319"/>
+            <a:chExt cx="1987902" cy="2043649"/>
           </a:xfrm>
         </p:grpSpPr>
         <p:sp>
@@ -14818,8 +15350,8 @@
           </p:nvSpPr>
           <p:spPr>
             <a:xfrm>
-              <a:off x="2289034" y="1759396"/>
-              <a:ext cx="540000" cy="540000"/>
+              <a:off x="2068312" y="1759395"/>
+              <a:ext cx="748922" cy="646331"/>
             </a:xfrm>
             <a:prstGeom prst="ellipse">
               <a:avLst/>
@@ -14852,6 +15384,19 @@
           <p:txBody>
             <a:bodyPr rtlCol="0" anchor="ctr"/>
             <a:lstStyle/>
+            <a:p>
+              <a:pPr algn="ctr"/>
+              <a:r>
+                <a:rPr kumimoji="1" lang="en-US" altLang="zh-TW" sz="1200" dirty="0">
+                  <a:solidFill>
+                    <a:schemeClr val="tx1"/>
+                  </a:solidFill>
+                  <a:latin typeface="Microsoft JhengHei UI" panose="020B0604030504040204" pitchFamily="34" charset="-120"/>
+                  <a:ea typeface="Microsoft JhengHei UI" panose="020B0604030504040204" pitchFamily="34" charset="-120"/>
+                </a:rPr>
+                <a:t>1</a:t>
+              </a:r>
+            </a:p>
             <a:p>
               <a:pPr algn="ctr"/>
               <a:r>
@@ -14932,6 +15477,19 @@
                   <a:latin typeface="Microsoft JhengHei UI" panose="020B0604030504040204" pitchFamily="34" charset="-120"/>
                   <a:ea typeface="Microsoft JhengHei UI" panose="020B0604030504040204" pitchFamily="34" charset="-120"/>
                 </a:rPr>
+                <a:t>3</a:t>
+              </a:r>
+            </a:p>
+            <a:p>
+              <a:pPr algn="ctr"/>
+              <a:r>
+                <a:rPr kumimoji="1" lang="en-US" altLang="zh-TW" sz="1200" dirty="0">
+                  <a:solidFill>
+                    <a:schemeClr val="tx1"/>
+                  </a:solidFill>
+                  <a:latin typeface="Microsoft JhengHei UI" panose="020B0604030504040204" pitchFamily="34" charset="-120"/>
+                  <a:ea typeface="Microsoft JhengHei UI" panose="020B0604030504040204" pitchFamily="34" charset="-120"/>
+                </a:rPr>
                 <a:t>n</a:t>
               </a:r>
               <a:endParaRPr kumimoji="1" lang="zh-TW" altLang="en-US" sz="1200" dirty="0">
@@ -14962,8 +15520,8 @@
           </p:nvCxnSpPr>
           <p:spPr>
             <a:xfrm flipH="1">
-              <a:off x="2559034" y="1537396"/>
-              <a:ext cx="284924" cy="222000"/>
+              <a:off x="2442773" y="1537396"/>
+              <a:ext cx="401185" cy="221999"/>
             </a:xfrm>
             <a:prstGeom prst="line">
               <a:avLst/>
@@ -15048,6 +15606,294 @@
           </p:txBody>
         </p:sp>
       </p:grpSp>
+      <p:sp>
+        <p:nvSpPr>
+          <p:cNvPr id="2" name="文字方塊 1">
+            <a:extLst>
+              <a:ext uri="{FF2B5EF4-FFF2-40B4-BE49-F238E27FC236}">
+                <a16:creationId xmlns:a16="http://schemas.microsoft.com/office/drawing/2014/main" id="{4F4947ED-B08B-40D5-7E3A-D60392296E70}"/>
+              </a:ext>
+            </a:extLst>
+          </p:cNvPr>
+          <p:cNvSpPr txBox="1"/>
+          <p:nvPr/>
+        </p:nvSpPr>
+        <p:spPr>
+          <a:xfrm>
+            <a:off x="582495" y="4077509"/>
+            <a:ext cx="748923" cy="276999"/>
+          </a:xfrm>
+          <a:prstGeom prst="rect">
+            <a:avLst/>
+          </a:prstGeom>
+          <a:noFill/>
+        </p:spPr>
+        <p:txBody>
+          <a:bodyPr wrap="none" rtlCol="0">
+            <a:spAutoFit/>
+          </a:bodyPr>
+          <a:lstStyle/>
+          <a:p>
+            <a:r>
+              <a:rPr kumimoji="1" lang="en-US" altLang="zh-TW" sz="1200" dirty="0">
+                <a:highlight>
+                  <a:srgbClr val="C0C0C0"/>
+                </a:highlight>
+                <a:latin typeface="Microsoft JhengHei UI" panose="020B0604030504040204" pitchFamily="34" charset="-120"/>
+                <a:ea typeface="Microsoft JhengHei UI" panose="020B0604030504040204" pitchFamily="34" charset="-120"/>
+              </a:rPr>
+              <a:t>case2-1</a:t>
+            </a:r>
+            <a:endParaRPr kumimoji="1" lang="zh-TW" altLang="en-US" sz="1200" dirty="0">
+              <a:highlight>
+                <a:srgbClr val="C0C0C0"/>
+              </a:highlight>
+              <a:latin typeface="Microsoft JhengHei UI" panose="020B0604030504040204" pitchFamily="34" charset="-120"/>
+              <a:ea typeface="Microsoft JhengHei UI" panose="020B0604030504040204" pitchFamily="34" charset="-120"/>
+            </a:endParaRPr>
+          </a:p>
+        </p:txBody>
+      </p:sp>
+      <p:sp>
+        <p:nvSpPr>
+          <p:cNvPr id="10" name="文字方塊 9">
+            <a:extLst>
+              <a:ext uri="{FF2B5EF4-FFF2-40B4-BE49-F238E27FC236}">
+                <a16:creationId xmlns:a16="http://schemas.microsoft.com/office/drawing/2014/main" id="{FF7F42ED-51EB-F6B7-AAFE-447D0C367F01}"/>
+              </a:ext>
+            </a:extLst>
+          </p:cNvPr>
+          <p:cNvSpPr txBox="1"/>
+          <p:nvPr/>
+        </p:nvSpPr>
+        <p:spPr>
+          <a:xfrm>
+            <a:off x="2453345" y="4592519"/>
+            <a:ext cx="748923" cy="276999"/>
+          </a:xfrm>
+          <a:prstGeom prst="rect">
+            <a:avLst/>
+          </a:prstGeom>
+          <a:noFill/>
+        </p:spPr>
+        <p:txBody>
+          <a:bodyPr wrap="none" rtlCol="0">
+            <a:spAutoFit/>
+          </a:bodyPr>
+          <a:lstStyle/>
+          <a:p>
+            <a:r>
+              <a:rPr kumimoji="1" lang="en-US" altLang="zh-TW" sz="1200" dirty="0">
+                <a:highlight>
+                  <a:srgbClr val="C0C0C0"/>
+                </a:highlight>
+                <a:latin typeface="Microsoft JhengHei UI" panose="020B0604030504040204" pitchFamily="34" charset="-120"/>
+                <a:ea typeface="Microsoft JhengHei UI" panose="020B0604030504040204" pitchFamily="34" charset="-120"/>
+              </a:rPr>
+              <a:t>case2-2</a:t>
+            </a:r>
+            <a:endParaRPr kumimoji="1" lang="zh-TW" altLang="en-US" sz="1200" dirty="0">
+              <a:highlight>
+                <a:srgbClr val="C0C0C0"/>
+              </a:highlight>
+              <a:latin typeface="Microsoft JhengHei UI" panose="020B0604030504040204" pitchFamily="34" charset="-120"/>
+              <a:ea typeface="Microsoft JhengHei UI" panose="020B0604030504040204" pitchFamily="34" charset="-120"/>
+            </a:endParaRPr>
+          </a:p>
+        </p:txBody>
+      </p:sp>
+      <p:sp>
+        <p:nvSpPr>
+          <p:cNvPr id="30" name="文字方塊 29">
+            <a:extLst>
+              <a:ext uri="{FF2B5EF4-FFF2-40B4-BE49-F238E27FC236}">
+                <a16:creationId xmlns:a16="http://schemas.microsoft.com/office/drawing/2014/main" id="{AD42BDE8-5BF7-3CB5-5FFB-5718D297DF70}"/>
+              </a:ext>
+            </a:extLst>
+          </p:cNvPr>
+          <p:cNvSpPr txBox="1"/>
+          <p:nvPr/>
+        </p:nvSpPr>
+        <p:spPr>
+          <a:xfrm>
+            <a:off x="5791519" y="3512289"/>
+            <a:ext cx="748923" cy="276999"/>
+          </a:xfrm>
+          <a:prstGeom prst="rect">
+            <a:avLst/>
+          </a:prstGeom>
+          <a:noFill/>
+        </p:spPr>
+        <p:txBody>
+          <a:bodyPr wrap="none" rtlCol="0">
+            <a:spAutoFit/>
+          </a:bodyPr>
+          <a:lstStyle/>
+          <a:p>
+            <a:r>
+              <a:rPr kumimoji="1" lang="en-US" altLang="zh-TW" sz="1200" dirty="0">
+                <a:highlight>
+                  <a:srgbClr val="C0C0C0"/>
+                </a:highlight>
+                <a:latin typeface="Microsoft JhengHei UI" panose="020B0604030504040204" pitchFamily="34" charset="-120"/>
+                <a:ea typeface="Microsoft JhengHei UI" panose="020B0604030504040204" pitchFamily="34" charset="-120"/>
+              </a:rPr>
+              <a:t>case2-3</a:t>
+            </a:r>
+            <a:endParaRPr kumimoji="1" lang="zh-TW" altLang="en-US" sz="1200" dirty="0">
+              <a:highlight>
+                <a:srgbClr val="C0C0C0"/>
+              </a:highlight>
+              <a:latin typeface="Microsoft JhengHei UI" panose="020B0604030504040204" pitchFamily="34" charset="-120"/>
+              <a:ea typeface="Microsoft JhengHei UI" panose="020B0604030504040204" pitchFamily="34" charset="-120"/>
+            </a:endParaRPr>
+          </a:p>
+        </p:txBody>
+      </p:sp>
+      <p:sp>
+        <p:nvSpPr>
+          <p:cNvPr id="31" name="文字方塊 30">
+            <a:extLst>
+              <a:ext uri="{FF2B5EF4-FFF2-40B4-BE49-F238E27FC236}">
+                <a16:creationId xmlns:a16="http://schemas.microsoft.com/office/drawing/2014/main" id="{B55A9779-5F61-6C56-D3A8-4B5CC321DB04}"/>
+              </a:ext>
+            </a:extLst>
+          </p:cNvPr>
+          <p:cNvSpPr txBox="1"/>
+          <p:nvPr/>
+        </p:nvSpPr>
+        <p:spPr>
+          <a:xfrm>
+            <a:off x="6333518" y="6096129"/>
+            <a:ext cx="748923" cy="276999"/>
+          </a:xfrm>
+          <a:prstGeom prst="rect">
+            <a:avLst/>
+          </a:prstGeom>
+          <a:noFill/>
+        </p:spPr>
+        <p:txBody>
+          <a:bodyPr wrap="none" rtlCol="0">
+            <a:spAutoFit/>
+          </a:bodyPr>
+          <a:lstStyle/>
+          <a:p>
+            <a:r>
+              <a:rPr kumimoji="1" lang="en-US" altLang="zh-TW" sz="1200" dirty="0">
+                <a:highlight>
+                  <a:srgbClr val="C0C0C0"/>
+                </a:highlight>
+                <a:latin typeface="Microsoft JhengHei UI" panose="020B0604030504040204" pitchFamily="34" charset="-120"/>
+                <a:ea typeface="Microsoft JhengHei UI" panose="020B0604030504040204" pitchFamily="34" charset="-120"/>
+              </a:rPr>
+              <a:t>case2-4</a:t>
+            </a:r>
+            <a:endParaRPr kumimoji="1" lang="zh-TW" altLang="en-US" sz="1200" dirty="0">
+              <a:highlight>
+                <a:srgbClr val="C0C0C0"/>
+              </a:highlight>
+              <a:latin typeface="Microsoft JhengHei UI" panose="020B0604030504040204" pitchFamily="34" charset="-120"/>
+              <a:ea typeface="Microsoft JhengHei UI" panose="020B0604030504040204" pitchFamily="34" charset="-120"/>
+            </a:endParaRPr>
+          </a:p>
+        </p:txBody>
+      </p:sp>
+      <p:sp>
+        <p:nvSpPr>
+          <p:cNvPr id="33" name="文字方塊 32">
+            <a:extLst>
+              <a:ext uri="{FF2B5EF4-FFF2-40B4-BE49-F238E27FC236}">
+                <a16:creationId xmlns:a16="http://schemas.microsoft.com/office/drawing/2014/main" id="{A9339044-BF7B-3E7E-FD2A-29FE62FA4DEA}"/>
+              </a:ext>
+            </a:extLst>
+          </p:cNvPr>
+          <p:cNvSpPr txBox="1"/>
+          <p:nvPr/>
+        </p:nvSpPr>
+        <p:spPr>
+          <a:xfrm>
+            <a:off x="10055245" y="3080110"/>
+            <a:ext cx="748923" cy="276999"/>
+          </a:xfrm>
+          <a:prstGeom prst="rect">
+            <a:avLst/>
+          </a:prstGeom>
+          <a:noFill/>
+        </p:spPr>
+        <p:txBody>
+          <a:bodyPr wrap="none" rtlCol="0">
+            <a:spAutoFit/>
+          </a:bodyPr>
+          <a:lstStyle/>
+          <a:p>
+            <a:r>
+              <a:rPr kumimoji="1" lang="en-US" altLang="zh-TW" sz="1200" dirty="0">
+                <a:highlight>
+                  <a:srgbClr val="C0C0C0"/>
+                </a:highlight>
+                <a:latin typeface="Microsoft JhengHei UI" panose="020B0604030504040204" pitchFamily="34" charset="-120"/>
+                <a:ea typeface="Microsoft JhengHei UI" panose="020B0604030504040204" pitchFamily="34" charset="-120"/>
+              </a:rPr>
+              <a:t>case2-5</a:t>
+            </a:r>
+            <a:endParaRPr kumimoji="1" lang="zh-TW" altLang="en-US" sz="1200" dirty="0">
+              <a:highlight>
+                <a:srgbClr val="C0C0C0"/>
+              </a:highlight>
+              <a:latin typeface="Microsoft JhengHei UI" panose="020B0604030504040204" pitchFamily="34" charset="-120"/>
+              <a:ea typeface="Microsoft JhengHei UI" panose="020B0604030504040204" pitchFamily="34" charset="-120"/>
+            </a:endParaRPr>
+          </a:p>
+        </p:txBody>
+      </p:sp>
+      <p:sp>
+        <p:nvSpPr>
+          <p:cNvPr id="35" name="文字方塊 34">
+            <a:extLst>
+              <a:ext uri="{FF2B5EF4-FFF2-40B4-BE49-F238E27FC236}">
+                <a16:creationId xmlns:a16="http://schemas.microsoft.com/office/drawing/2014/main" id="{8E09854B-FEC5-ED4A-02FD-CF2F83F823D4}"/>
+              </a:ext>
+            </a:extLst>
+          </p:cNvPr>
+          <p:cNvSpPr txBox="1"/>
+          <p:nvPr/>
+        </p:nvSpPr>
+        <p:spPr>
+          <a:xfrm>
+            <a:off x="10202991" y="6010749"/>
+            <a:ext cx="748923" cy="276999"/>
+          </a:xfrm>
+          <a:prstGeom prst="rect">
+            <a:avLst/>
+          </a:prstGeom>
+          <a:noFill/>
+        </p:spPr>
+        <p:txBody>
+          <a:bodyPr wrap="none" rtlCol="0">
+            <a:spAutoFit/>
+          </a:bodyPr>
+          <a:lstStyle/>
+          <a:p>
+            <a:r>
+              <a:rPr kumimoji="1" lang="en-US" altLang="zh-TW" sz="1200" dirty="0">
+                <a:highlight>
+                  <a:srgbClr val="C0C0C0"/>
+                </a:highlight>
+                <a:latin typeface="Microsoft JhengHei UI" panose="020B0604030504040204" pitchFamily="34" charset="-120"/>
+                <a:ea typeface="Microsoft JhengHei UI" panose="020B0604030504040204" pitchFamily="34" charset="-120"/>
+              </a:rPr>
+              <a:t>case2-6</a:t>
+            </a:r>
+            <a:endParaRPr kumimoji="1" lang="zh-TW" altLang="en-US" sz="1200" dirty="0">
+              <a:highlight>
+                <a:srgbClr val="C0C0C0"/>
+              </a:highlight>
+              <a:latin typeface="Microsoft JhengHei UI" panose="020B0604030504040204" pitchFamily="34" charset="-120"/>
+              <a:ea typeface="Microsoft JhengHei UI" panose="020B0604030504040204" pitchFamily="34" charset="-120"/>
+            </a:endParaRPr>
+          </a:p>
+        </p:txBody>
+      </p:sp>
     </p:spTree>
     <p:extLst>
       <p:ext uri="{BB962C8B-B14F-4D97-AF65-F5344CB8AC3E}">
@@ -15938,6 +16784,19 @@
                   <a:latin typeface="Microsoft JhengHei UI" panose="020B0604030504040204" pitchFamily="34" charset="-120"/>
                   <a:ea typeface="Microsoft JhengHei UI" panose="020B0604030504040204" pitchFamily="34" charset="-120"/>
                 </a:rPr>
+                <a:t>2</a:t>
+              </a:r>
+            </a:p>
+            <a:p>
+              <a:pPr algn="ctr"/>
+              <a:r>
+                <a:rPr kumimoji="1" lang="en-US" altLang="zh-TW" sz="1200" dirty="0">
+                  <a:solidFill>
+                    <a:schemeClr val="tx1"/>
+                  </a:solidFill>
+                  <a:latin typeface="Microsoft JhengHei UI" panose="020B0604030504040204" pitchFamily="34" charset="-120"/>
+                  <a:ea typeface="Microsoft JhengHei UI" panose="020B0604030504040204" pitchFamily="34" charset="-120"/>
+                </a:rPr>
                 <a:t>m</a:t>
               </a:r>
               <a:endParaRPr kumimoji="1" lang="zh-TW" altLang="en-US" sz="1200" dirty="0">
@@ -15998,6 +16857,19 @@
           <p:txBody>
             <a:bodyPr rtlCol="0" anchor="ctr"/>
             <a:lstStyle/>
+            <a:p>
+              <a:pPr algn="ctr"/>
+              <a:r>
+                <a:rPr kumimoji="1" lang="en-US" altLang="zh-TW" sz="1200" dirty="0">
+                  <a:solidFill>
+                    <a:schemeClr val="tx1"/>
+                  </a:solidFill>
+                  <a:latin typeface="Microsoft JhengHei UI" panose="020B0604030504040204" pitchFamily="34" charset="-120"/>
+                  <a:ea typeface="Microsoft JhengHei UI" panose="020B0604030504040204" pitchFamily="34" charset="-120"/>
+                </a:rPr>
+                <a:t>3</a:t>
+              </a:r>
+            </a:p>
             <a:p>
               <a:pPr algn="ctr"/>
               <a:r>
@@ -16070,6 +16942,16 @@
             <a:lstStyle/>
             <a:p>
               <a:pPr algn="ctr"/>
+              <a:r>
+                <a:rPr kumimoji="1" lang="en-US" altLang="zh-TW" sz="1200" dirty="0">
+                  <a:solidFill>
+                    <a:schemeClr val="tx1"/>
+                  </a:solidFill>
+                  <a:latin typeface="Microsoft JhengHei UI" panose="020B0604030504040204" pitchFamily="34" charset="-120"/>
+                  <a:ea typeface="Microsoft JhengHei UI" panose="020B0604030504040204" pitchFamily="34" charset="-120"/>
+                </a:rPr>
+                <a:t>4</a:t>
+              </a:r>
               <a:endParaRPr kumimoji="1" lang="zh-TW" altLang="en-US" sz="1200" dirty="0">
                 <a:solidFill>
                   <a:schemeClr val="tx1"/>
@@ -16316,7 +17198,7 @@
         <p:spPr>
           <a:xfrm>
             <a:off x="98367" y="569997"/>
-            <a:ext cx="7557005" cy="369332"/>
+            <a:ext cx="7814319" cy="369332"/>
           </a:xfrm>
           <a:prstGeom prst="rect">
             <a:avLst/>
@@ -16334,7 +17216,7 @@
                 <a:latin typeface="Microsoft JhengHei UI" panose="020B0604030504040204" pitchFamily="34" charset="-120"/>
                 <a:ea typeface="Microsoft JhengHei UI" panose="020B0604030504040204" pitchFamily="34" charset="-120"/>
               </a:rPr>
-              <a:t>Case 3A: (to-be-deleted) node has two children (P = None, N = root)</a:t>
+              <a:t>Pattern 3A: (to-be-deleted) node has two children (P = None, N = root)</a:t>
             </a:r>
             <a:endParaRPr kumimoji="1" lang="zh-TW" altLang="en-US" u="sng" dirty="0">
               <a:latin typeface="Microsoft JhengHei UI" panose="020B0604030504040204" pitchFamily="34" charset="-120"/>
@@ -16391,6 +17273,19 @@
         <p:txBody>
           <a:bodyPr rtlCol="0" anchor="ctr"/>
           <a:lstStyle/>
+          <a:p>
+            <a:pPr algn="ctr"/>
+            <a:r>
+              <a:rPr kumimoji="1" lang="en-US" altLang="zh-TW" sz="1200" dirty="0">
+                <a:solidFill>
+                  <a:schemeClr val="tx1"/>
+                </a:solidFill>
+                <a:latin typeface="Microsoft JhengHei UI" panose="020B0604030504040204" pitchFamily="34" charset="-120"/>
+                <a:ea typeface="Microsoft JhengHei UI" panose="020B0604030504040204" pitchFamily="34" charset="-120"/>
+              </a:rPr>
+              <a:t>2</a:t>
+            </a:r>
+          </a:p>
           <a:p>
             <a:pPr algn="ctr"/>
             <a:r>
@@ -16471,6 +17366,19 @@
                 <a:latin typeface="Microsoft JhengHei UI" panose="020B0604030504040204" pitchFamily="34" charset="-120"/>
                 <a:ea typeface="Microsoft JhengHei UI" panose="020B0604030504040204" pitchFamily="34" charset="-120"/>
               </a:rPr>
+              <a:t>4</a:t>
+            </a:r>
+          </a:p>
+          <a:p>
+            <a:pPr algn="ctr"/>
+            <a:r>
+              <a:rPr kumimoji="1" lang="en-US" altLang="zh-TW" sz="1200" dirty="0">
+                <a:solidFill>
+                  <a:schemeClr val="tx1"/>
+                </a:solidFill>
+                <a:latin typeface="Microsoft JhengHei UI" panose="020B0604030504040204" pitchFamily="34" charset="-120"/>
+                <a:ea typeface="Microsoft JhengHei UI" panose="020B0604030504040204" pitchFamily="34" charset="-120"/>
+              </a:rPr>
               <a:t>n</a:t>
             </a:r>
             <a:endParaRPr kumimoji="1" lang="zh-TW" altLang="en-US" sz="1200" dirty="0">
@@ -16533,6 +17441,16 @@
           <a:lstStyle/>
           <a:p>
             <a:pPr algn="ctr"/>
+            <a:r>
+              <a:rPr kumimoji="1" lang="en-US" altLang="zh-TW" sz="1200" dirty="0">
+                <a:solidFill>
+                  <a:schemeClr val="tx1"/>
+                </a:solidFill>
+                <a:latin typeface="Microsoft JhengHei UI" panose="020B0604030504040204" pitchFamily="34" charset="-120"/>
+                <a:ea typeface="Microsoft JhengHei UI" panose="020B0604030504040204" pitchFamily="34" charset="-120"/>
+              </a:rPr>
+              <a:t>5</a:t>
+            </a:r>
             <a:endParaRPr kumimoji="1" lang="zh-TW" altLang="en-US" sz="1200" dirty="0">
               <a:solidFill>
                 <a:schemeClr val="tx1"/>
@@ -16589,6 +17507,19 @@
         <p:txBody>
           <a:bodyPr rtlCol="0" anchor="ctr"/>
           <a:lstStyle/>
+          <a:p>
+            <a:pPr algn="ctr"/>
+            <a:r>
+              <a:rPr kumimoji="1" lang="en-US" altLang="zh-TW" sz="1200" dirty="0">
+                <a:solidFill>
+                  <a:schemeClr val="tx1"/>
+                </a:solidFill>
+                <a:latin typeface="Microsoft JhengHei UI" panose="020B0604030504040204" pitchFamily="34" charset="-120"/>
+                <a:ea typeface="Microsoft JhengHei UI" panose="020B0604030504040204" pitchFamily="34" charset="-120"/>
+              </a:rPr>
+              <a:t>3</a:t>
+            </a:r>
+          </a:p>
           <a:p>
             <a:pPr algn="ctr"/>
             <a:r>
@@ -16823,6 +17754,19 @@
             <a:p>
               <a:pPr algn="ctr"/>
               <a:r>
+                <a:rPr kumimoji="1" lang="en-US" altLang="zh-TW" sz="1200" dirty="0">
+                  <a:solidFill>
+                    <a:schemeClr val="tx1"/>
+                  </a:solidFill>
+                  <a:latin typeface="Microsoft JhengHei UI" panose="020B0604030504040204" pitchFamily="34" charset="-120"/>
+                  <a:ea typeface="Microsoft JhengHei UI" panose="020B0604030504040204" pitchFamily="34" charset="-120"/>
+                </a:rPr>
+                <a:t>4</a:t>
+              </a:r>
+            </a:p>
+            <a:p>
+              <a:pPr algn="ctr"/>
+              <a:r>
                 <a:rPr kumimoji="1" lang="en-US" altLang="zh-TW" sz="1200" dirty="0" err="1">
                   <a:solidFill>
                     <a:schemeClr val="tx1"/>
@@ -16890,6 +17834,19 @@
           <p:txBody>
             <a:bodyPr rtlCol="0" anchor="ctr"/>
             <a:lstStyle/>
+            <a:p>
+              <a:pPr algn="ctr"/>
+              <a:r>
+                <a:rPr kumimoji="1" lang="en-US" altLang="zh-TW" sz="1200" dirty="0">
+                  <a:solidFill>
+                    <a:schemeClr val="tx1"/>
+                  </a:solidFill>
+                  <a:latin typeface="Microsoft JhengHei UI" panose="020B0604030504040204" pitchFamily="34" charset="-120"/>
+                  <a:ea typeface="Microsoft JhengHei UI" panose="020B0604030504040204" pitchFamily="34" charset="-120"/>
+                </a:rPr>
+                <a:t>8</a:t>
+              </a:r>
+            </a:p>
             <a:p>
               <a:pPr algn="ctr"/>
               <a:r>
@@ -16962,6 +17919,16 @@
             <a:lstStyle/>
             <a:p>
               <a:pPr algn="ctr"/>
+              <a:r>
+                <a:rPr kumimoji="1" lang="en-US" altLang="zh-TW" sz="1200" dirty="0">
+                  <a:solidFill>
+                    <a:schemeClr val="tx1"/>
+                  </a:solidFill>
+                  <a:latin typeface="Microsoft JhengHei UI" panose="020B0604030504040204" pitchFamily="34" charset="-120"/>
+                  <a:ea typeface="Microsoft JhengHei UI" panose="020B0604030504040204" pitchFamily="34" charset="-120"/>
+                </a:rPr>
+                <a:t>9</a:t>
+              </a:r>
               <a:endParaRPr kumimoji="1" lang="zh-TW" altLang="en-US" sz="1200" dirty="0">
                 <a:solidFill>
                   <a:schemeClr val="tx1"/>
@@ -17020,6 +17987,16 @@
             <a:lstStyle/>
             <a:p>
               <a:pPr algn="ctr"/>
+              <a:r>
+                <a:rPr kumimoji="1" lang="en-US" altLang="zh-TW" sz="1200" dirty="0">
+                  <a:solidFill>
+                    <a:schemeClr val="tx1"/>
+                  </a:solidFill>
+                  <a:latin typeface="Microsoft JhengHei UI" panose="020B0604030504040204" pitchFamily="34" charset="-120"/>
+                  <a:ea typeface="Microsoft JhengHei UI" panose="020B0604030504040204" pitchFamily="34" charset="-120"/>
+                </a:rPr>
+                <a:t>3</a:t>
+              </a:r>
               <a:endParaRPr kumimoji="1" lang="zh-TW" altLang="en-US" sz="1200" dirty="0">
                 <a:solidFill>
                   <a:schemeClr val="tx1"/>
@@ -17219,6 +18196,19 @@
           <p:txBody>
             <a:bodyPr rtlCol="0" anchor="ctr"/>
             <a:lstStyle/>
+            <a:p>
+              <a:pPr algn="ctr"/>
+              <a:r>
+                <a:rPr kumimoji="1" lang="en-US" altLang="zh-TW" sz="1200" dirty="0">
+                  <a:solidFill>
+                    <a:schemeClr val="tx1"/>
+                  </a:solidFill>
+                  <a:latin typeface="Microsoft JhengHei UI" panose="020B0604030504040204" pitchFamily="34" charset="-120"/>
+                  <a:ea typeface="Microsoft JhengHei UI" panose="020B0604030504040204" pitchFamily="34" charset="-120"/>
+                </a:rPr>
+                <a:t>6</a:t>
+              </a:r>
+            </a:p>
             <a:p>
               <a:pPr algn="ctr"/>
               <a:r>
@@ -17338,6 +18328,16 @@
             <a:lstStyle/>
             <a:p>
               <a:pPr algn="ctr"/>
+              <a:r>
+                <a:rPr kumimoji="1" lang="en-US" altLang="zh-TW" sz="1200" dirty="0">
+                  <a:solidFill>
+                    <a:schemeClr val="tx1"/>
+                  </a:solidFill>
+                  <a:latin typeface="Microsoft JhengHei UI" panose="020B0604030504040204" pitchFamily="34" charset="-120"/>
+                  <a:ea typeface="Microsoft JhengHei UI" panose="020B0604030504040204" pitchFamily="34" charset="-120"/>
+                </a:rPr>
+                <a:t>1</a:t>
+              </a:r>
               <a:endParaRPr kumimoji="1" lang="zh-TW" altLang="en-US" sz="1200" dirty="0">
                 <a:solidFill>
                   <a:schemeClr val="tx1"/>
@@ -17446,6 +18446,16 @@
           <a:lstStyle/>
           <a:p>
             <a:pPr algn="ctr"/>
+            <a:r>
+              <a:rPr kumimoji="1" lang="en-US" altLang="zh-TW" sz="1200" dirty="0">
+                <a:solidFill>
+                  <a:schemeClr val="tx1"/>
+                </a:solidFill>
+                <a:latin typeface="Microsoft JhengHei UI" panose="020B0604030504040204" pitchFamily="34" charset="-120"/>
+                <a:ea typeface="Microsoft JhengHei UI" panose="020B0604030504040204" pitchFamily="34" charset="-120"/>
+              </a:rPr>
+              <a:t>5</a:t>
+            </a:r>
             <a:endParaRPr kumimoji="1" lang="zh-TW" altLang="en-US" sz="1200" dirty="0">
               <a:solidFill>
                 <a:schemeClr val="tx1"/>
@@ -17503,6 +18513,198 @@
           </a:fontRef>
         </p:style>
       </p:cxnSp>
+      <p:sp>
+        <p:nvSpPr>
+          <p:cNvPr id="3" name="文字方塊 2">
+            <a:extLst>
+              <a:ext uri="{FF2B5EF4-FFF2-40B4-BE49-F238E27FC236}">
+                <a16:creationId xmlns:a16="http://schemas.microsoft.com/office/drawing/2014/main" id="{5F648004-22AC-AAC6-6E5A-1F18204E7A3D}"/>
+              </a:ext>
+            </a:extLst>
+          </p:cNvPr>
+          <p:cNvSpPr txBox="1"/>
+          <p:nvPr/>
+        </p:nvSpPr>
+        <p:spPr>
+          <a:xfrm>
+            <a:off x="582495" y="4077509"/>
+            <a:ext cx="856325" cy="276999"/>
+          </a:xfrm>
+          <a:prstGeom prst="rect">
+            <a:avLst/>
+          </a:prstGeom>
+          <a:noFill/>
+        </p:spPr>
+        <p:txBody>
+          <a:bodyPr wrap="none" rtlCol="0">
+            <a:spAutoFit/>
+          </a:bodyPr>
+          <a:lstStyle/>
+          <a:p>
+            <a:r>
+              <a:rPr kumimoji="1" lang="en-US" altLang="zh-TW" sz="1200" dirty="0">
+                <a:highlight>
+                  <a:srgbClr val="C0C0C0"/>
+                </a:highlight>
+                <a:latin typeface="Microsoft JhengHei UI" panose="020B0604030504040204" pitchFamily="34" charset="-120"/>
+                <a:ea typeface="Microsoft JhengHei UI" panose="020B0604030504040204" pitchFamily="34" charset="-120"/>
+              </a:rPr>
+              <a:t>case3A-1</a:t>
+            </a:r>
+            <a:endParaRPr kumimoji="1" lang="zh-TW" altLang="en-US" sz="1200" dirty="0">
+              <a:highlight>
+                <a:srgbClr val="C0C0C0"/>
+              </a:highlight>
+              <a:latin typeface="Microsoft JhengHei UI" panose="020B0604030504040204" pitchFamily="34" charset="-120"/>
+              <a:ea typeface="Microsoft JhengHei UI" panose="020B0604030504040204" pitchFamily="34" charset="-120"/>
+            </a:endParaRPr>
+          </a:p>
+        </p:txBody>
+      </p:sp>
+      <p:sp>
+        <p:nvSpPr>
+          <p:cNvPr id="5" name="文字方塊 4">
+            <a:extLst>
+              <a:ext uri="{FF2B5EF4-FFF2-40B4-BE49-F238E27FC236}">
+                <a16:creationId xmlns:a16="http://schemas.microsoft.com/office/drawing/2014/main" id="{2F18079E-CF87-E41B-363B-9E01192435CD}"/>
+              </a:ext>
+            </a:extLst>
+          </p:cNvPr>
+          <p:cNvSpPr txBox="1"/>
+          <p:nvPr/>
+        </p:nvSpPr>
+        <p:spPr>
+          <a:xfrm>
+            <a:off x="3660230" y="4835305"/>
+            <a:ext cx="856325" cy="276999"/>
+          </a:xfrm>
+          <a:prstGeom prst="rect">
+            <a:avLst/>
+          </a:prstGeom>
+          <a:noFill/>
+        </p:spPr>
+        <p:txBody>
+          <a:bodyPr wrap="none" rtlCol="0">
+            <a:spAutoFit/>
+          </a:bodyPr>
+          <a:lstStyle/>
+          <a:p>
+            <a:r>
+              <a:rPr kumimoji="1" lang="en-US" altLang="zh-TW" sz="1200" dirty="0">
+                <a:highlight>
+                  <a:srgbClr val="C0C0C0"/>
+                </a:highlight>
+                <a:latin typeface="Microsoft JhengHei UI" panose="020B0604030504040204" pitchFamily="34" charset="-120"/>
+                <a:ea typeface="Microsoft JhengHei UI" panose="020B0604030504040204" pitchFamily="34" charset="-120"/>
+              </a:rPr>
+              <a:t>case3A-2</a:t>
+            </a:r>
+            <a:endParaRPr kumimoji="1" lang="zh-TW" altLang="en-US" sz="1200" dirty="0">
+              <a:highlight>
+                <a:srgbClr val="C0C0C0"/>
+              </a:highlight>
+              <a:latin typeface="Microsoft JhengHei UI" panose="020B0604030504040204" pitchFamily="34" charset="-120"/>
+              <a:ea typeface="Microsoft JhengHei UI" panose="020B0604030504040204" pitchFamily="34" charset="-120"/>
+            </a:endParaRPr>
+          </a:p>
+        </p:txBody>
+      </p:sp>
+      <p:sp>
+        <p:nvSpPr>
+          <p:cNvPr id="6" name="文字方塊 5">
+            <a:extLst>
+              <a:ext uri="{FF2B5EF4-FFF2-40B4-BE49-F238E27FC236}">
+                <a16:creationId xmlns:a16="http://schemas.microsoft.com/office/drawing/2014/main" id="{57EA0D7B-DC41-1304-C399-ADFDF21C7334}"/>
+              </a:ext>
+            </a:extLst>
+          </p:cNvPr>
+          <p:cNvSpPr txBox="1"/>
+          <p:nvPr/>
+        </p:nvSpPr>
+        <p:spPr>
+          <a:xfrm>
+            <a:off x="6859517" y="4550514"/>
+            <a:ext cx="856325" cy="276999"/>
+          </a:xfrm>
+          <a:prstGeom prst="rect">
+            <a:avLst/>
+          </a:prstGeom>
+          <a:noFill/>
+        </p:spPr>
+        <p:txBody>
+          <a:bodyPr wrap="none" rtlCol="0">
+            <a:spAutoFit/>
+          </a:bodyPr>
+          <a:lstStyle/>
+          <a:p>
+            <a:r>
+              <a:rPr kumimoji="1" lang="en-US" altLang="zh-TW" sz="1200" dirty="0">
+                <a:highlight>
+                  <a:srgbClr val="C0C0C0"/>
+                </a:highlight>
+                <a:latin typeface="Microsoft JhengHei UI" panose="020B0604030504040204" pitchFamily="34" charset="-120"/>
+                <a:ea typeface="Microsoft JhengHei UI" panose="020B0604030504040204" pitchFamily="34" charset="-120"/>
+              </a:rPr>
+              <a:t>case3A-3</a:t>
+            </a:r>
+            <a:endParaRPr kumimoji="1" lang="zh-TW" altLang="en-US" sz="1200" dirty="0">
+              <a:highlight>
+                <a:srgbClr val="C0C0C0"/>
+              </a:highlight>
+              <a:latin typeface="Microsoft JhengHei UI" panose="020B0604030504040204" pitchFamily="34" charset="-120"/>
+              <a:ea typeface="Microsoft JhengHei UI" panose="020B0604030504040204" pitchFamily="34" charset="-120"/>
+            </a:endParaRPr>
+          </a:p>
+        </p:txBody>
+      </p:sp>
+      <p:sp>
+        <p:nvSpPr>
+          <p:cNvPr id="7" name="文字方塊 6">
+            <a:extLst>
+              <a:ext uri="{FF2B5EF4-FFF2-40B4-BE49-F238E27FC236}">
+                <a16:creationId xmlns:a16="http://schemas.microsoft.com/office/drawing/2014/main" id="{894DAE83-D422-16C0-5DA3-5BC708F18905}"/>
+              </a:ext>
+            </a:extLst>
+          </p:cNvPr>
+          <p:cNvSpPr txBox="1"/>
+          <p:nvPr/>
+        </p:nvSpPr>
+        <p:spPr>
+          <a:xfrm>
+            <a:off x="9327074" y="5128651"/>
+            <a:ext cx="856325" cy="276999"/>
+          </a:xfrm>
+          <a:prstGeom prst="rect">
+            <a:avLst/>
+          </a:prstGeom>
+          <a:noFill/>
+        </p:spPr>
+        <p:txBody>
+          <a:bodyPr wrap="none" rtlCol="0">
+            <a:spAutoFit/>
+          </a:bodyPr>
+          <a:lstStyle/>
+          <a:p>
+            <a:r>
+              <a:rPr kumimoji="1" lang="en-US" altLang="zh-TW" sz="1200" dirty="0">
+                <a:highlight>
+                  <a:srgbClr val="C0C0C0"/>
+                </a:highlight>
+                <a:latin typeface="Microsoft JhengHei UI" panose="020B0604030504040204" pitchFamily="34" charset="-120"/>
+                <a:ea typeface="Microsoft JhengHei UI" panose="020B0604030504040204" pitchFamily="34" charset="-120"/>
+              </a:rPr>
+              <a:t>case3A-4</a:t>
+            </a:r>
+            <a:endParaRPr kumimoji="1" lang="zh-TW" altLang="en-US" sz="1200" dirty="0">
+              <a:highlight>
+                <a:srgbClr val="C0C0C0"/>
+              </a:highlight>
+              <a:latin typeface="Microsoft JhengHei UI" panose="020B0604030504040204" pitchFamily="34" charset="-120"/>
+              <a:ea typeface="Microsoft JhengHei UI" panose="020B0604030504040204" pitchFamily="34" charset="-120"/>
+            </a:endParaRPr>
+          </a:p>
+        </p:txBody>
+      </p:sp>
     </p:spTree>
     <p:extLst>
       <p:ext uri="{BB962C8B-B14F-4D97-AF65-F5344CB8AC3E}">
@@ -17751,6 +18953,19 @@
                   <a:latin typeface="Microsoft JhengHei UI" panose="020B0604030504040204" pitchFamily="34" charset="-120"/>
                   <a:ea typeface="Microsoft JhengHei UI" panose="020B0604030504040204" pitchFamily="34" charset="-120"/>
                 </a:rPr>
+                <a:t>3</a:t>
+              </a:r>
+            </a:p>
+            <a:p>
+              <a:pPr algn="ctr"/>
+              <a:r>
+                <a:rPr kumimoji="1" lang="en-US" altLang="zh-TW" sz="1200" dirty="0">
+                  <a:solidFill>
+                    <a:schemeClr val="tx1"/>
+                  </a:solidFill>
+                  <a:latin typeface="Microsoft JhengHei UI" panose="020B0604030504040204" pitchFamily="34" charset="-120"/>
+                  <a:ea typeface="Microsoft JhengHei UI" panose="020B0604030504040204" pitchFamily="34" charset="-120"/>
+                </a:rPr>
                 <a:t>n</a:t>
               </a:r>
               <a:endParaRPr kumimoji="1" lang="zh-TW" altLang="en-US" sz="1200" dirty="0">
@@ -17811,6 +19026,19 @@
           <p:txBody>
             <a:bodyPr rtlCol="0" anchor="ctr"/>
             <a:lstStyle/>
+            <a:p>
+              <a:pPr algn="ctr"/>
+              <a:r>
+                <a:rPr kumimoji="1" lang="en-US" altLang="zh-TW" sz="1200" dirty="0">
+                  <a:solidFill>
+                    <a:schemeClr val="tx1"/>
+                  </a:solidFill>
+                  <a:latin typeface="Microsoft JhengHei UI" panose="020B0604030504040204" pitchFamily="34" charset="-120"/>
+                  <a:ea typeface="Microsoft JhengHei UI" panose="020B0604030504040204" pitchFamily="34" charset="-120"/>
+                </a:rPr>
+                <a:t>6</a:t>
+              </a:r>
+            </a:p>
             <a:p>
               <a:pPr algn="ctr"/>
               <a:r>
@@ -17883,6 +19111,16 @@
             <a:lstStyle/>
             <a:p>
               <a:pPr algn="ctr"/>
+              <a:r>
+                <a:rPr kumimoji="1" lang="en-US" altLang="zh-TW" sz="1200" dirty="0">
+                  <a:solidFill>
+                    <a:schemeClr val="tx1"/>
+                  </a:solidFill>
+                  <a:latin typeface="Microsoft JhengHei UI" panose="020B0604030504040204" pitchFamily="34" charset="-120"/>
+                  <a:ea typeface="Microsoft JhengHei UI" panose="020B0604030504040204" pitchFamily="34" charset="-120"/>
+                </a:rPr>
+                <a:t>7</a:t>
+              </a:r>
               <a:endParaRPr kumimoji="1" lang="zh-TW" altLang="en-US" sz="1200" dirty="0">
                 <a:solidFill>
                   <a:schemeClr val="tx1"/>
@@ -17949,7 +19187,7 @@
                   <a:latin typeface="Microsoft JhengHei UI" panose="020B0604030504040204" pitchFamily="34" charset="-120"/>
                   <a:ea typeface="Microsoft JhengHei UI" panose="020B0604030504040204" pitchFamily="34" charset="-120"/>
                 </a:rPr>
-                <a:t>m</a:t>
+                <a:t>2m</a:t>
               </a:r>
               <a:endParaRPr kumimoji="1" lang="zh-TW" altLang="en-US" sz="1200" dirty="0">
                 <a:solidFill>
@@ -18152,6 +19390,16 @@
             <a:lstStyle/>
             <a:p>
               <a:pPr algn="ctr"/>
+              <a:r>
+                <a:rPr kumimoji="1" lang="en-US" altLang="zh-TW" sz="1200" dirty="0">
+                  <a:solidFill>
+                    <a:schemeClr val="tx1"/>
+                  </a:solidFill>
+                  <a:latin typeface="Microsoft JhengHei UI" panose="020B0604030504040204" pitchFamily="34" charset="-120"/>
+                  <a:ea typeface="Microsoft JhengHei UI" panose="020B0604030504040204" pitchFamily="34" charset="-120"/>
+                </a:rPr>
+                <a:t>4</a:t>
+              </a:r>
               <a:endParaRPr kumimoji="1" lang="zh-TW" altLang="en-US" sz="1200" dirty="0">
                 <a:solidFill>
                   <a:schemeClr val="tx1"/>
@@ -18259,6 +19507,16 @@
             <a:lstStyle/>
             <a:p>
               <a:pPr algn="ctr"/>
+              <a:r>
+                <a:rPr kumimoji="1" lang="en-US" altLang="zh-TW" sz="1200" dirty="0">
+                  <a:solidFill>
+                    <a:schemeClr val="tx1"/>
+                  </a:solidFill>
+                  <a:latin typeface="Microsoft JhengHei UI" panose="020B0604030504040204" pitchFamily="34" charset="-120"/>
+                  <a:ea typeface="Microsoft JhengHei UI" panose="020B0604030504040204" pitchFamily="34" charset="-120"/>
+                </a:rPr>
+                <a:t>5</a:t>
+              </a:r>
               <a:endParaRPr kumimoji="1" lang="zh-TW" altLang="en-US" sz="1200" dirty="0">
                 <a:solidFill>
                   <a:schemeClr val="tx1"/>
@@ -18367,14 +19625,14 @@
             <a:p>
               <a:pPr algn="ctr"/>
               <a:r>
-                <a:rPr kumimoji="1" lang="en-US" altLang="zh-TW" sz="1200" dirty="0" err="1">
+                <a:rPr kumimoji="1" lang="en-US" altLang="zh-TW" sz="1200" dirty="0">
                   <a:solidFill>
                     <a:schemeClr val="tx1"/>
                   </a:solidFill>
                   <a:latin typeface="Microsoft JhengHei UI" panose="020B0604030504040204" pitchFamily="34" charset="-120"/>
                   <a:ea typeface="Microsoft JhengHei UI" panose="020B0604030504040204" pitchFamily="34" charset="-120"/>
                 </a:rPr>
-                <a:t>m.p</a:t>
+                <a:t>1m.p</a:t>
               </a:r>
               <a:endParaRPr kumimoji="1" lang="zh-TW" altLang="en-US" sz="1200" dirty="0">
                 <a:solidFill>
@@ -18575,6 +19833,19 @@
                   <a:latin typeface="Microsoft JhengHei UI" panose="020B0604030504040204" pitchFamily="34" charset="-120"/>
                   <a:ea typeface="Microsoft JhengHei UI" panose="020B0604030504040204" pitchFamily="34" charset="-120"/>
                 </a:rPr>
+                <a:t>5</a:t>
+              </a:r>
+            </a:p>
+            <a:p>
+              <a:pPr algn="ctr"/>
+              <a:r>
+                <a:rPr kumimoji="1" lang="en-US" altLang="zh-TW" sz="1200" dirty="0">
+                  <a:solidFill>
+                    <a:schemeClr val="tx1"/>
+                  </a:solidFill>
+                  <a:latin typeface="Microsoft JhengHei UI" panose="020B0604030504040204" pitchFamily="34" charset="-120"/>
+                  <a:ea typeface="Microsoft JhengHei UI" panose="020B0604030504040204" pitchFamily="34" charset="-120"/>
+                </a:rPr>
                 <a:t>n</a:t>
               </a:r>
               <a:endParaRPr kumimoji="1" lang="zh-TW" altLang="en-US" sz="1200" dirty="0">
@@ -18635,6 +19906,19 @@
           <p:txBody>
             <a:bodyPr rtlCol="0" anchor="ctr"/>
             <a:lstStyle/>
+            <a:p>
+              <a:pPr algn="ctr"/>
+              <a:r>
+                <a:rPr kumimoji="1" lang="en-US" altLang="zh-TW" sz="1200" dirty="0">
+                  <a:solidFill>
+                    <a:schemeClr val="tx1"/>
+                  </a:solidFill>
+                  <a:latin typeface="Microsoft JhengHei UI" panose="020B0604030504040204" pitchFamily="34" charset="-120"/>
+                  <a:ea typeface="Microsoft JhengHei UI" panose="020B0604030504040204" pitchFamily="34" charset="-120"/>
+                </a:rPr>
+                <a:t>8</a:t>
+              </a:r>
+            </a:p>
             <a:p>
               <a:pPr algn="ctr"/>
               <a:r>
@@ -18707,6 +19991,16 @@
             <a:lstStyle/>
             <a:p>
               <a:pPr algn="ctr"/>
+              <a:r>
+                <a:rPr kumimoji="1" lang="en-US" altLang="zh-TW" sz="1200" dirty="0">
+                  <a:solidFill>
+                    <a:schemeClr val="tx1"/>
+                  </a:solidFill>
+                  <a:latin typeface="Microsoft JhengHei UI" panose="020B0604030504040204" pitchFamily="34" charset="-120"/>
+                  <a:ea typeface="Microsoft JhengHei UI" panose="020B0604030504040204" pitchFamily="34" charset="-120"/>
+                </a:rPr>
+                <a:t>9</a:t>
+              </a:r>
               <a:endParaRPr kumimoji="1" lang="zh-TW" altLang="en-US" sz="1200" dirty="0">
                 <a:solidFill>
                   <a:schemeClr val="tx1"/>
@@ -18763,6 +20057,19 @@
           <p:txBody>
             <a:bodyPr rtlCol="0" anchor="ctr"/>
             <a:lstStyle/>
+            <a:p>
+              <a:pPr algn="ctr"/>
+              <a:r>
+                <a:rPr kumimoji="1" lang="en-US" altLang="zh-TW" sz="1200" dirty="0">
+                  <a:solidFill>
+                    <a:schemeClr val="tx1"/>
+                  </a:solidFill>
+                  <a:latin typeface="Microsoft JhengHei UI" panose="020B0604030504040204" pitchFamily="34" charset="-120"/>
+                  <a:ea typeface="Microsoft JhengHei UI" panose="020B0604030504040204" pitchFamily="34" charset="-120"/>
+                </a:rPr>
+                <a:t>2</a:t>
+              </a:r>
+            </a:p>
             <a:p>
               <a:pPr algn="ctr"/>
               <a:r>
@@ -18976,6 +20283,16 @@
             <a:lstStyle/>
             <a:p>
               <a:pPr algn="ctr"/>
+              <a:r>
+                <a:rPr kumimoji="1" lang="en-US" altLang="zh-TW" sz="1200" dirty="0">
+                  <a:solidFill>
+                    <a:schemeClr val="tx1"/>
+                  </a:solidFill>
+                  <a:latin typeface="Microsoft JhengHei UI" panose="020B0604030504040204" pitchFamily="34" charset="-120"/>
+                  <a:ea typeface="Microsoft JhengHei UI" panose="020B0604030504040204" pitchFamily="34" charset="-120"/>
+                </a:rPr>
+                <a:t>6</a:t>
+              </a:r>
               <a:endParaRPr kumimoji="1" lang="zh-TW" altLang="en-US" sz="1200" dirty="0">
                 <a:solidFill>
                   <a:schemeClr val="tx1"/>
@@ -19079,6 +20396,19 @@
           <p:txBody>
             <a:bodyPr rtlCol="0" anchor="ctr"/>
             <a:lstStyle/>
+            <a:p>
+              <a:pPr algn="ctr"/>
+              <a:r>
+                <a:rPr kumimoji="1" lang="en-US" altLang="zh-TW" sz="1200" dirty="0">
+                  <a:solidFill>
+                    <a:schemeClr val="tx1"/>
+                  </a:solidFill>
+                  <a:latin typeface="Microsoft JhengHei UI" panose="020B0604030504040204" pitchFamily="34" charset="-120"/>
+                  <a:ea typeface="Microsoft JhengHei UI" panose="020B0604030504040204" pitchFamily="34" charset="-120"/>
+                </a:rPr>
+                <a:t>4</a:t>
+              </a:r>
+            </a:p>
             <a:p>
               <a:pPr algn="ctr"/>
               <a:r>
@@ -19149,6 +20479,16 @@
             <a:lstStyle/>
             <a:p>
               <a:pPr algn="ctr"/>
+              <a:r>
+                <a:rPr kumimoji="1" lang="en-US" altLang="zh-TW" sz="1200" dirty="0">
+                  <a:solidFill>
+                    <a:schemeClr val="tx1"/>
+                  </a:solidFill>
+                  <a:latin typeface="Microsoft JhengHei UI" panose="020B0604030504040204" pitchFamily="34" charset="-120"/>
+                  <a:ea typeface="Microsoft JhengHei UI" panose="020B0604030504040204" pitchFamily="34" charset="-120"/>
+                </a:rPr>
+                <a:t>3</a:t>
+              </a:r>
               <a:endParaRPr kumimoji="1" lang="zh-TW" altLang="en-US" sz="1200" dirty="0">
                 <a:solidFill>
                   <a:schemeClr val="tx1"/>
@@ -19254,6 +20594,16 @@
             <a:lstStyle/>
             <a:p>
               <a:pPr algn="ctr"/>
+              <a:r>
+                <a:rPr kumimoji="1" lang="en-US" altLang="zh-TW" sz="1200" dirty="0">
+                  <a:solidFill>
+                    <a:schemeClr val="tx1"/>
+                  </a:solidFill>
+                  <a:latin typeface="Microsoft JhengHei UI" panose="020B0604030504040204" pitchFamily="34" charset="-120"/>
+                  <a:ea typeface="Microsoft JhengHei UI" panose="020B0604030504040204" pitchFamily="34" charset="-120"/>
+                </a:rPr>
+                <a:t>1</a:t>
+              </a:r>
               <a:endParaRPr kumimoji="1" lang="zh-TW" altLang="en-US" sz="1200" dirty="0">
                 <a:solidFill>
                   <a:schemeClr val="tx1"/>
@@ -19408,6 +20758,16 @@
             <a:lstStyle/>
             <a:p>
               <a:pPr algn="ctr"/>
+              <a:r>
+                <a:rPr kumimoji="1" lang="en-US" altLang="zh-TW" sz="1200" dirty="0">
+                  <a:solidFill>
+                    <a:schemeClr val="tx1"/>
+                  </a:solidFill>
+                  <a:latin typeface="Microsoft JhengHei UI" panose="020B0604030504040204" pitchFamily="34" charset="-120"/>
+                  <a:ea typeface="Microsoft JhengHei UI" panose="020B0604030504040204" pitchFamily="34" charset="-120"/>
+                </a:rPr>
+                <a:t>7</a:t>
+              </a:r>
               <a:endParaRPr kumimoji="1" lang="zh-TW" altLang="en-US" sz="1200" dirty="0">
                 <a:solidFill>
                   <a:schemeClr val="tx1"/>
@@ -19429,15 +20789,15 @@
             </p:cNvPr>
             <p:cNvCxnSpPr>
               <a:cxnSpLocks/>
-              <a:stCxn id="72" idx="4"/>
+              <a:stCxn id="72" idx="6"/>
               <a:endCxn id="95" idx="0"/>
             </p:cNvCxnSpPr>
             <p:nvPr/>
           </p:nvCxnSpPr>
           <p:spPr>
             <a:xfrm>
-              <a:off x="2047604" y="4050712"/>
-              <a:ext cx="467262" cy="347210"/>
+              <a:off x="2317604" y="3780712"/>
+              <a:ext cx="197262" cy="617210"/>
             </a:xfrm>
             <a:prstGeom prst="line">
               <a:avLst/>
@@ -19544,6 +20904,19 @@
                   <a:latin typeface="Microsoft JhengHei UI" panose="020B0604030504040204" pitchFamily="34" charset="-120"/>
                   <a:ea typeface="Microsoft JhengHei UI" panose="020B0604030504040204" pitchFamily="34" charset="-120"/>
                 </a:rPr>
+                <a:t>2</a:t>
+              </a:r>
+            </a:p>
+            <a:p>
+              <a:pPr algn="ctr"/>
+              <a:r>
+                <a:rPr kumimoji="1" lang="en-US" altLang="zh-TW" sz="1200" dirty="0">
+                  <a:solidFill>
+                    <a:schemeClr val="tx1"/>
+                  </a:solidFill>
+                  <a:latin typeface="Microsoft JhengHei UI" panose="020B0604030504040204" pitchFamily="34" charset="-120"/>
+                  <a:ea typeface="Microsoft JhengHei UI" panose="020B0604030504040204" pitchFamily="34" charset="-120"/>
+                </a:rPr>
                 <a:t>n</a:t>
               </a:r>
               <a:endParaRPr kumimoji="1" lang="zh-TW" altLang="en-US" sz="1200" dirty="0">
@@ -19604,6 +20977,19 @@
           <p:txBody>
             <a:bodyPr rtlCol="0" anchor="ctr"/>
             <a:lstStyle/>
+            <a:p>
+              <a:pPr algn="ctr"/>
+              <a:r>
+                <a:rPr kumimoji="1" lang="en-US" altLang="zh-TW" sz="1200" dirty="0">
+                  <a:solidFill>
+                    <a:schemeClr val="tx1"/>
+                  </a:solidFill>
+                  <a:latin typeface="Microsoft JhengHei UI" panose="020B0604030504040204" pitchFamily="34" charset="-120"/>
+                  <a:ea typeface="Microsoft JhengHei UI" panose="020B0604030504040204" pitchFamily="34" charset="-120"/>
+                </a:rPr>
+                <a:t>4</a:t>
+              </a:r>
+            </a:p>
             <a:p>
               <a:pPr algn="ctr"/>
               <a:r>
@@ -19676,6 +21062,16 @@
             <a:lstStyle/>
             <a:p>
               <a:pPr algn="ctr"/>
+              <a:r>
+                <a:rPr kumimoji="1" lang="en-US" altLang="zh-TW" sz="1200" dirty="0">
+                  <a:solidFill>
+                    <a:schemeClr val="tx1"/>
+                  </a:solidFill>
+                  <a:latin typeface="Microsoft JhengHei UI" panose="020B0604030504040204" pitchFamily="34" charset="-120"/>
+                  <a:ea typeface="Microsoft JhengHei UI" panose="020B0604030504040204" pitchFamily="34" charset="-120"/>
+                </a:rPr>
+                <a:t>5</a:t>
+              </a:r>
               <a:endParaRPr kumimoji="1" lang="zh-TW" altLang="en-US" sz="1200" dirty="0">
                 <a:solidFill>
                   <a:schemeClr val="tx1"/>
@@ -19732,6 +21128,19 @@
           <p:txBody>
             <a:bodyPr rtlCol="0" anchor="ctr"/>
             <a:lstStyle/>
+            <a:p>
+              <a:pPr algn="ctr"/>
+              <a:r>
+                <a:rPr kumimoji="1" lang="en-US" altLang="zh-TW" sz="1200" dirty="0">
+                  <a:solidFill>
+                    <a:schemeClr val="tx1"/>
+                  </a:solidFill>
+                  <a:latin typeface="Microsoft JhengHei UI" panose="020B0604030504040204" pitchFamily="34" charset="-120"/>
+                  <a:ea typeface="Microsoft JhengHei UI" panose="020B0604030504040204" pitchFamily="34" charset="-120"/>
+                </a:rPr>
+                <a:t>1</a:t>
+              </a:r>
+            </a:p>
             <a:p>
               <a:pPr algn="ctr"/>
               <a:r>
@@ -20008,6 +21417,16 @@
             <a:lstStyle/>
             <a:p>
               <a:pPr algn="ctr"/>
+              <a:r>
+                <a:rPr kumimoji="1" lang="en-US" altLang="zh-TW" sz="1200" dirty="0">
+                  <a:solidFill>
+                    <a:schemeClr val="tx1"/>
+                  </a:solidFill>
+                  <a:latin typeface="Microsoft JhengHei UI" panose="020B0604030504040204" pitchFamily="34" charset="-120"/>
+                  <a:ea typeface="Microsoft JhengHei UI" panose="020B0604030504040204" pitchFamily="34" charset="-120"/>
+                </a:rPr>
+                <a:t>3</a:t>
+              </a:r>
               <a:endParaRPr kumimoji="1" lang="zh-TW" altLang="en-US" sz="1200" dirty="0">
                 <a:solidFill>
                   <a:schemeClr val="tx1"/>
@@ -20144,6 +21563,19 @@
                   <a:latin typeface="Microsoft JhengHei UI" panose="020B0604030504040204" pitchFamily="34" charset="-120"/>
                   <a:ea typeface="Microsoft JhengHei UI" panose="020B0604030504040204" pitchFamily="34" charset="-120"/>
                 </a:rPr>
+                <a:t>4</a:t>
+              </a:r>
+            </a:p>
+            <a:p>
+              <a:pPr algn="ctr"/>
+              <a:r>
+                <a:rPr kumimoji="1" lang="en-US" altLang="zh-TW" sz="1200" dirty="0">
+                  <a:solidFill>
+                    <a:schemeClr val="tx1"/>
+                  </a:solidFill>
+                  <a:latin typeface="Microsoft JhengHei UI" panose="020B0604030504040204" pitchFamily="34" charset="-120"/>
+                  <a:ea typeface="Microsoft JhengHei UI" panose="020B0604030504040204" pitchFamily="34" charset="-120"/>
+                </a:rPr>
                 <a:t>n</a:t>
               </a:r>
               <a:endParaRPr kumimoji="1" lang="zh-TW" altLang="en-US" sz="1200" dirty="0">
@@ -20204,6 +21636,19 @@
           <p:txBody>
             <a:bodyPr rtlCol="0" anchor="ctr"/>
             <a:lstStyle/>
+            <a:p>
+              <a:pPr algn="ctr"/>
+              <a:r>
+                <a:rPr kumimoji="1" lang="en-US" altLang="zh-TW" sz="1200" dirty="0">
+                  <a:solidFill>
+                    <a:schemeClr val="tx1"/>
+                  </a:solidFill>
+                  <a:latin typeface="Microsoft JhengHei UI" panose="020B0604030504040204" pitchFamily="34" charset="-120"/>
+                  <a:ea typeface="Microsoft JhengHei UI" panose="020B0604030504040204" pitchFamily="34" charset="-120"/>
+                </a:rPr>
+                <a:t>6</a:t>
+              </a:r>
+            </a:p>
             <a:p>
               <a:pPr algn="ctr"/>
               <a:r>
@@ -20276,6 +21721,16 @@
             <a:lstStyle/>
             <a:p>
               <a:pPr algn="ctr"/>
+              <a:r>
+                <a:rPr kumimoji="1" lang="en-US" altLang="zh-TW" sz="1200" dirty="0">
+                  <a:solidFill>
+                    <a:schemeClr val="tx1"/>
+                  </a:solidFill>
+                  <a:latin typeface="Microsoft JhengHei UI" panose="020B0604030504040204" pitchFamily="34" charset="-120"/>
+                  <a:ea typeface="Microsoft JhengHei UI" panose="020B0604030504040204" pitchFamily="34" charset="-120"/>
+                </a:rPr>
+                <a:t>7</a:t>
+              </a:r>
               <a:endParaRPr kumimoji="1" lang="zh-TW" altLang="en-US" sz="1200" dirty="0">
                 <a:solidFill>
                   <a:schemeClr val="tx1"/>
@@ -20332,6 +21787,19 @@
           <p:txBody>
             <a:bodyPr rtlCol="0" anchor="ctr"/>
             <a:lstStyle/>
+            <a:p>
+              <a:pPr algn="ctr"/>
+              <a:r>
+                <a:rPr kumimoji="1" lang="en-US" altLang="zh-TW" sz="1200" dirty="0">
+                  <a:solidFill>
+                    <a:schemeClr val="tx1"/>
+                  </a:solidFill>
+                  <a:latin typeface="Microsoft JhengHei UI" panose="020B0604030504040204" pitchFamily="34" charset="-120"/>
+                  <a:ea typeface="Microsoft JhengHei UI" panose="020B0604030504040204" pitchFamily="34" charset="-120"/>
+                </a:rPr>
+                <a:t>3</a:t>
+              </a:r>
+            </a:p>
             <a:p>
               <a:pPr algn="ctr"/>
               <a:r>
@@ -20608,6 +22076,16 @@
             <a:lstStyle/>
             <a:p>
               <a:pPr algn="ctr"/>
+              <a:r>
+                <a:rPr kumimoji="1" lang="en-US" altLang="zh-TW" sz="1200" dirty="0">
+                  <a:solidFill>
+                    <a:schemeClr val="tx1"/>
+                  </a:solidFill>
+                  <a:latin typeface="Microsoft JhengHei UI" panose="020B0604030504040204" pitchFamily="34" charset="-120"/>
+                  <a:ea typeface="Microsoft JhengHei UI" panose="020B0604030504040204" pitchFamily="34" charset="-120"/>
+                </a:rPr>
+                <a:t>5</a:t>
+              </a:r>
               <a:endParaRPr kumimoji="1" lang="zh-TW" altLang="en-US" sz="1200" dirty="0">
                 <a:solidFill>
                   <a:schemeClr val="tx1"/>
@@ -20715,6 +22193,16 @@
             <a:lstStyle/>
             <a:p>
               <a:pPr algn="ctr"/>
+              <a:r>
+                <a:rPr kumimoji="1" lang="en-US" altLang="zh-TW" sz="1200" dirty="0">
+                  <a:solidFill>
+                    <a:schemeClr val="tx1"/>
+                  </a:solidFill>
+                  <a:latin typeface="Microsoft JhengHei UI" panose="020B0604030504040204" pitchFamily="34" charset="-120"/>
+                  <a:ea typeface="Microsoft JhengHei UI" panose="020B0604030504040204" pitchFamily="34" charset="-120"/>
+                </a:rPr>
+                <a:t>2</a:t>
+              </a:r>
               <a:endParaRPr kumimoji="1" lang="zh-TW" altLang="en-US" sz="1200" dirty="0">
                 <a:solidFill>
                   <a:schemeClr val="tx1"/>
@@ -20788,7 +22276,7 @@
         <p:spPr>
           <a:xfrm>
             <a:off x="98367" y="569997"/>
-            <a:ext cx="6970370" cy="369332"/>
+            <a:ext cx="7521033" cy="369332"/>
           </a:xfrm>
           <a:prstGeom prst="rect">
             <a:avLst/>
@@ -20802,20 +22290,205 @@
           <a:lstStyle/>
           <a:p>
             <a:r>
-              <a:rPr kumimoji="1" lang="en-US" altLang="zh-TW" u="sng">
-                <a:latin typeface="Microsoft JhengHei UI" panose="020B0604030504040204" pitchFamily="34" charset="-120"/>
-                <a:ea typeface="Microsoft JhengHei UI" panose="020B0604030504040204" pitchFamily="34" charset="-120"/>
-              </a:rPr>
-              <a:t>Case 3B: </a:t>
-            </a:r>
-            <a:r>
               <a:rPr kumimoji="1" lang="en-US" altLang="zh-TW" u="sng" dirty="0">
                 <a:latin typeface="Microsoft JhengHei UI" panose="020B0604030504040204" pitchFamily="34" charset="-120"/>
                 <a:ea typeface="Microsoft JhengHei UI" panose="020B0604030504040204" pitchFamily="34" charset="-120"/>
               </a:rPr>
-              <a:t>(to-be-deleted) node has two children (P = Not None)</a:t>
+              <a:t>Pattern 3B: (to-be-deleted) node has two children (P = Not None)</a:t>
             </a:r>
             <a:endParaRPr kumimoji="1" lang="zh-TW" altLang="en-US" u="sng" dirty="0">
+              <a:latin typeface="Microsoft JhengHei UI" panose="020B0604030504040204" pitchFamily="34" charset="-120"/>
+              <a:ea typeface="Microsoft JhengHei UI" panose="020B0604030504040204" pitchFamily="34" charset="-120"/>
+            </a:endParaRPr>
+          </a:p>
+        </p:txBody>
+      </p:sp>
+      <p:sp>
+        <p:nvSpPr>
+          <p:cNvPr id="14" name="文字方塊 13">
+            <a:extLst>
+              <a:ext uri="{FF2B5EF4-FFF2-40B4-BE49-F238E27FC236}">
+                <a16:creationId xmlns:a16="http://schemas.microsoft.com/office/drawing/2014/main" id="{2272B486-0818-F2A1-FEDB-CDEBA4AB821B}"/>
+              </a:ext>
+            </a:extLst>
+          </p:cNvPr>
+          <p:cNvSpPr txBox="1"/>
+          <p:nvPr/>
+        </p:nvSpPr>
+        <p:spPr>
+          <a:xfrm>
+            <a:off x="582495" y="4077509"/>
+            <a:ext cx="856325" cy="276999"/>
+          </a:xfrm>
+          <a:prstGeom prst="rect">
+            <a:avLst/>
+          </a:prstGeom>
+          <a:noFill/>
+        </p:spPr>
+        <p:txBody>
+          <a:bodyPr wrap="none" rtlCol="0">
+            <a:spAutoFit/>
+          </a:bodyPr>
+          <a:lstStyle/>
+          <a:p>
+            <a:r>
+              <a:rPr kumimoji="1" lang="en-US" altLang="zh-TW" sz="1200" dirty="0">
+                <a:highlight>
+                  <a:srgbClr val="C0C0C0"/>
+                </a:highlight>
+                <a:latin typeface="Microsoft JhengHei UI" panose="020B0604030504040204" pitchFamily="34" charset="-120"/>
+                <a:ea typeface="Microsoft JhengHei UI" panose="020B0604030504040204" pitchFamily="34" charset="-120"/>
+              </a:rPr>
+              <a:t>case3B-1</a:t>
+            </a:r>
+            <a:endParaRPr kumimoji="1" lang="zh-TW" altLang="en-US" sz="1200" dirty="0">
+              <a:highlight>
+                <a:srgbClr val="C0C0C0"/>
+              </a:highlight>
+              <a:latin typeface="Microsoft JhengHei UI" panose="020B0604030504040204" pitchFamily="34" charset="-120"/>
+              <a:ea typeface="Microsoft JhengHei UI" panose="020B0604030504040204" pitchFamily="34" charset="-120"/>
+            </a:endParaRPr>
+          </a:p>
+        </p:txBody>
+      </p:sp>
+      <p:sp>
+        <p:nvSpPr>
+          <p:cNvPr id="15" name="文字方塊 14">
+            <a:extLst>
+              <a:ext uri="{FF2B5EF4-FFF2-40B4-BE49-F238E27FC236}">
+                <a16:creationId xmlns:a16="http://schemas.microsoft.com/office/drawing/2014/main" id="{48031B94-F7F2-68CA-F887-D668AB68348F}"/>
+              </a:ext>
+            </a:extLst>
+          </p:cNvPr>
+          <p:cNvSpPr txBox="1"/>
+          <p:nvPr/>
+        </p:nvSpPr>
+        <p:spPr>
+          <a:xfrm>
+            <a:off x="4200561" y="4633936"/>
+            <a:ext cx="843501" cy="276999"/>
+          </a:xfrm>
+          <a:prstGeom prst="rect">
+            <a:avLst/>
+          </a:prstGeom>
+          <a:noFill/>
+        </p:spPr>
+        <p:txBody>
+          <a:bodyPr wrap="none" rtlCol="0">
+            <a:spAutoFit/>
+          </a:bodyPr>
+          <a:lstStyle/>
+          <a:p>
+            <a:r>
+              <a:rPr kumimoji="1" lang="en-US" altLang="zh-TW" sz="1200" dirty="0">
+                <a:highlight>
+                  <a:srgbClr val="C0C0C0"/>
+                </a:highlight>
+                <a:latin typeface="Microsoft JhengHei UI" panose="020B0604030504040204" pitchFamily="34" charset="-120"/>
+                <a:ea typeface="Microsoft JhengHei UI" panose="020B0604030504040204" pitchFamily="34" charset="-120"/>
+              </a:rPr>
+              <a:t>case3B-2</a:t>
+            </a:r>
+            <a:endParaRPr kumimoji="1" lang="zh-TW" altLang="en-US" sz="1200" dirty="0">
+              <a:highlight>
+                <a:srgbClr val="C0C0C0"/>
+              </a:highlight>
+              <a:latin typeface="Microsoft JhengHei UI" panose="020B0604030504040204" pitchFamily="34" charset="-120"/>
+              <a:ea typeface="Microsoft JhengHei UI" panose="020B0604030504040204" pitchFamily="34" charset="-120"/>
+            </a:endParaRPr>
+          </a:p>
+        </p:txBody>
+      </p:sp>
+      <p:sp>
+        <p:nvSpPr>
+          <p:cNvPr id="18" name="文字方塊 17">
+            <a:extLst>
+              <a:ext uri="{FF2B5EF4-FFF2-40B4-BE49-F238E27FC236}">
+                <a16:creationId xmlns:a16="http://schemas.microsoft.com/office/drawing/2014/main" id="{23000C25-F53F-9E11-7FCC-321090C729A3}"/>
+              </a:ext>
+            </a:extLst>
+          </p:cNvPr>
+          <p:cNvSpPr txBox="1"/>
+          <p:nvPr/>
+        </p:nvSpPr>
+        <p:spPr>
+          <a:xfrm>
+            <a:off x="6720410" y="5099475"/>
+            <a:ext cx="856325" cy="276999"/>
+          </a:xfrm>
+          <a:prstGeom prst="rect">
+            <a:avLst/>
+          </a:prstGeom>
+          <a:noFill/>
+        </p:spPr>
+        <p:txBody>
+          <a:bodyPr wrap="none" rtlCol="0">
+            <a:spAutoFit/>
+          </a:bodyPr>
+          <a:lstStyle/>
+          <a:p>
+            <a:r>
+              <a:rPr kumimoji="1" lang="en-US" altLang="zh-TW" sz="1200" dirty="0">
+                <a:highlight>
+                  <a:srgbClr val="C0C0C0"/>
+                </a:highlight>
+                <a:latin typeface="Microsoft JhengHei UI" panose="020B0604030504040204" pitchFamily="34" charset="-120"/>
+                <a:ea typeface="Microsoft JhengHei UI" panose="020B0604030504040204" pitchFamily="34" charset="-120"/>
+              </a:rPr>
+              <a:t>case3B-3</a:t>
+            </a:r>
+            <a:endParaRPr kumimoji="1" lang="zh-TW" altLang="en-US" sz="1200" dirty="0">
+              <a:highlight>
+                <a:srgbClr val="C0C0C0"/>
+              </a:highlight>
+              <a:latin typeface="Microsoft JhengHei UI" panose="020B0604030504040204" pitchFamily="34" charset="-120"/>
+              <a:ea typeface="Microsoft JhengHei UI" panose="020B0604030504040204" pitchFamily="34" charset="-120"/>
+            </a:endParaRPr>
+          </a:p>
+        </p:txBody>
+      </p:sp>
+      <p:sp>
+        <p:nvSpPr>
+          <p:cNvPr id="20" name="文字方塊 19">
+            <a:extLst>
+              <a:ext uri="{FF2B5EF4-FFF2-40B4-BE49-F238E27FC236}">
+                <a16:creationId xmlns:a16="http://schemas.microsoft.com/office/drawing/2014/main" id="{3EC02B1E-B50C-9D99-25EE-902E9D5A92B5}"/>
+              </a:ext>
+            </a:extLst>
+          </p:cNvPr>
+          <p:cNvSpPr txBox="1"/>
+          <p:nvPr/>
+        </p:nvSpPr>
+        <p:spPr>
+          <a:xfrm>
+            <a:off x="10211128" y="5515081"/>
+            <a:ext cx="856325" cy="276999"/>
+          </a:xfrm>
+          <a:prstGeom prst="rect">
+            <a:avLst/>
+          </a:prstGeom>
+          <a:noFill/>
+        </p:spPr>
+        <p:txBody>
+          <a:bodyPr wrap="none" rtlCol="0">
+            <a:spAutoFit/>
+          </a:bodyPr>
+          <a:lstStyle/>
+          <a:p>
+            <a:r>
+              <a:rPr kumimoji="1" lang="en-US" altLang="zh-TW" sz="1200" dirty="0">
+                <a:highlight>
+                  <a:srgbClr val="C0C0C0"/>
+                </a:highlight>
+                <a:latin typeface="Microsoft JhengHei UI" panose="020B0604030504040204" pitchFamily="34" charset="-120"/>
+                <a:ea typeface="Microsoft JhengHei UI" panose="020B0604030504040204" pitchFamily="34" charset="-120"/>
+              </a:rPr>
+              <a:t>case3B-4</a:t>
+            </a:r>
+            <a:endParaRPr kumimoji="1" lang="zh-TW" altLang="en-US" sz="1200" dirty="0">
+              <a:highlight>
+                <a:srgbClr val="C0C0C0"/>
+              </a:highlight>
               <a:latin typeface="Microsoft JhengHei UI" panose="020B0604030504040204" pitchFamily="34" charset="-120"/>
               <a:ea typeface="Microsoft JhengHei UI" panose="020B0604030504040204" pitchFamily="34" charset="-120"/>
             </a:endParaRPr>

</xml_diff>